<commit_message>
Add Phase 2: venue revenue model, under-monetization flags, expansion ranking
Gradient-boosted-trees model predicts realized ad revenue from venue
characteristics plus Phase 1's RCT-calibrated per-exposure lift as a
feature. 5-fold out-of-fold predictions power under-monetization flags on
existing venues; the same model scores never-before-seen prospect venues
for expansion priority. Synthetic data injects a latent true-potential and
monetization-efficiency structure (never given to the model) to validate
recovery (0.95 correlation) before trusting the flags conceptually -- same
ground-truth-first discipline as Phase 1. Adds a 5th Streamlit tab and two
new deck slides; updates README and honest-scope notes accordingly.

Co-Authored-By: Claude Sonnet 5 <noreply@anthropic.com>
Claude-Session: https://claude.ai/code/session_017jyLbEVWfmSvvuhbbFmqiC
</commit_message>
<xml_diff>
--- a/deck/AtmosphereTV_DOOH_Measurement.pptx
+++ b/deck/AtmosphereTV_DOOH_Measurement.pptx
@@ -16,9 +16,10 @@
     <p:sldId id="264" r:id="rId10"/>
     <p:sldId id="265" r:id="rId11"/>
     <p:sldId id="266" r:id="rId12"/>
+    <p:sldId id="267" r:id="rId13"/>
   </p:sldIdLst>
   <p:notesMasterIdLst>
-    <p:notesMasterId r:id="rId13"/>
+    <p:notesMasterId r:id="rId14"/>
   </p:notesMasterIdLst>
   <p:sldSz cx="12192000" cy="6858000"/>
   <p:notesSz cx="6858000" cy="12192000"/>
@@ -1586,6 +1587,281 @@
 </c:chartSpace>
 </file>
 
+<file path=ppt/charts/chart5.xml><?xml version="1.0" encoding="utf-8"?>
+<c:chartSpace xmlns:c="http://schemas.openxmlformats.org/drawingml/2006/chart" xmlns:a="http://schemas.openxmlformats.org/drawingml/2006/main" xmlns:r="http://schemas.openxmlformats.org/officeDocument/2006/relationships">
+  <c:date1904 val="0"/>
+  <c:roundedCorners val="1"/>
+  <c:chart>
+    <c:title>
+      <c:tx>
+        <c:rich>
+          <a:bodyPr/>
+          <a:lstStyle/>
+          <a:p>
+            <a:pPr>
+              <a:defRPr sz="1150" b="0" i="0" u="none" strike="noStrike">
+                <a:solidFill>
+                  <a:srgbClr val="1E2761"/>
+                </a:solidFill>
+                <a:latin typeface="Arial"/>
+              </a:defRPr>
+            </a:pPr>
+            <a:r>
+              <a:rPr sz="1150" b="0" i="0" u="none" strike="noStrike">
+                <a:solidFill>
+                  <a:srgbClr val="1E2761"/>
+                </a:solidFill>
+                <a:latin typeface="Arial"/>
+              </a:rPr>
+              <a:t>Feature importance (permutation, test set)</a:t>
+            </a:r>
+          </a:p>
+        </c:rich>
+      </c:tx>
+      <c:layout/>
+      <c:overlay val="0"/>
+    </c:title>
+    <c:autoTitleDeleted val="0"/>
+    <c:plotArea>
+      <c:layout/>
+      <c:barChart>
+        <c:barDir val="bar"/>
+        <c:grouping val="clustered"/>
+        <c:varyColors val="0"/>
+        <c:ser>
+          <c:idx val="0"/>
+          <c:order val="0"/>
+          <c:tx>
+            <c:strRef>
+              <c:f>Sheet1!$B$1</c:f>
+              <c:strCache>
+                <c:ptCount val="1"/>
+                <c:pt idx="0">
+                  <c:v>Importance (mean R² drop)</c:v>
+                </c:pt>
+              </c:strCache>
+            </c:strRef>
+          </c:tx>
+          <c:spPr>
+            <a:solidFill>
+              <a:srgbClr val="55A868"/>
+            </a:solidFill>
+            <a:effectLst/>
+          </c:spPr>
+          <c:invertIfNegative val="0"/>
+          <c:dLbls>
+            <c:numFmt formatCode="0.00" sourceLinked="0"/>
+            <c:txPr>
+              <a:bodyPr/>
+              <a:lstStyle/>
+              <a:p>
+                <a:pPr>
+                  <a:defRPr b="0" i="0" strike="noStrike" sz="900" u="none">
+                    <a:solidFill>
+                      <a:srgbClr val="000000"/>
+                    </a:solidFill>
+                    <a:latin typeface="Arial"/>
+                  </a:defRPr>
+                </a:pPr>
+              </a:p>
+            </c:txPr>
+            <c:showLegendKey val="0"/>
+            <c:showVal val="1"/>
+            <c:showCatName val="0"/>
+            <c:showSerName val="0"/>
+            <c:showPercent val="0"/>
+            <c:showBubbleSize val="0"/>
+            <c:showLeaderLines val="0"/>
+          </c:dLbls>
+          <c:cat>
+            <c:multiLvlStrRef>
+              <c:f>Sheet1!$A$2:$A$5</c:f>
+              <c:multiLvlStrCache>
+                <c:ptCount val="4"/>
+                <c:lvl>
+                  <c:pt idx="0">
+                    <c:v>dwell time min</c:v>
+                  </c:pt>
+                  <c:pt idx="1">
+                    <c:v>audience quality</c:v>
+                  </c:pt>
+                  <c:pt idx="2">
+                    <c:v>geo cluster</c:v>
+                  </c:pt>
+                  <c:pt idx="3">
+                    <c:v>baseline level</c:v>
+                  </c:pt>
+                </c:lvl>
+              </c:multiLvlStrCache>
+            </c:multiLvlStrRef>
+          </c:cat>
+          <c:val>
+            <c:numRef>
+              <c:f>Sheet1!$B$2:$B$5</c:f>
+              <c:numCache>
+                <c:formatCode>General</c:formatCode>
+                <c:ptCount val="4"/>
+                <c:pt idx="0">
+                  <c:v>0.075</c:v>
+                </c:pt>
+                <c:pt idx="1">
+                  <c:v>0.142</c:v>
+                </c:pt>
+                <c:pt idx="2">
+                  <c:v>0.269</c:v>
+                </c:pt>
+                <c:pt idx="3">
+                  <c:v>0.813</c:v>
+                </c:pt>
+              </c:numCache>
+            </c:numRef>
+          </c:val>
+        </c:ser>
+        <c:dLbls>
+          <c:numFmt formatCode="0.00" sourceLinked="0"/>
+          <c:txPr>
+            <a:bodyPr/>
+            <a:lstStyle/>
+            <a:p>
+              <a:pPr>
+                <a:defRPr b="0" i="0" strike="noStrike" sz="900" u="none">
+                  <a:solidFill>
+                    <a:srgbClr val="000000"/>
+                  </a:solidFill>
+                  <a:latin typeface="Arial"/>
+                </a:defRPr>
+              </a:pPr>
+            </a:p>
+          </c:txPr>
+          <c:showLegendKey val="0"/>
+          <c:showVal val="1"/>
+          <c:showCatName val="0"/>
+          <c:showSerName val="0"/>
+          <c:showPercent val="0"/>
+          <c:showBubbleSize val="0"/>
+          <c:showLeaderLines val="0"/>
+        </c:dLbls>
+        <c:gapWidth val="150"/>
+        <c:overlap val="0"/>
+        <c:axId val="2094734554"/>
+        <c:axId val="2094734552"/>
+        <c:axId val="2094734556"/>
+      </c:barChart>
+      <c:catAx>
+        <c:axId val="2094734554"/>
+        <c:scaling>
+          <c:orientation val="minMax"/>
+        </c:scaling>
+        <c:delete val="0"/>
+        <c:axPos val="l"/>
+        <c:numFmt formatCode="General" sourceLinked="1"/>
+        <c:majorTickMark val="out"/>
+        <c:minorTickMark val="none"/>
+        <c:tickLblPos val="nextTo"/>
+        <c:spPr>
+          <a:ln w="12700" cap="flat">
+            <a:solidFill>
+              <a:srgbClr val="888888"/>
+            </a:solidFill>
+            <a:prstDash val="solid"/>
+            <a:round/>
+          </a:ln>
+        </c:spPr>
+        <c:txPr>
+          <a:bodyPr/>
+          <a:lstStyle/>
+          <a:p>
+            <a:pPr>
+              <a:defRPr sz="1000" b="0" i="0" u="none" strike="noStrike">
+                <a:solidFill>
+                  <a:srgbClr val="1A1A2E"/>
+                </a:solidFill>
+                <a:latin typeface="Arial"/>
+              </a:defRPr>
+            </a:pPr>
+            <a:endParaRPr lang="en-US"/>
+          </a:p>
+        </c:txPr>
+        <c:crossAx val="2094734552"/>
+        <c:crosses val="autoZero"/>
+        <c:auto val="1"/>
+        <c:lblAlgn val="ctr"/>
+        <c:noMultiLvlLbl val="1"/>
+      </c:catAx>
+      <c:valAx>
+        <c:axId val="2094734552"/>
+        <c:scaling>
+          <c:orientation val="minMax"/>
+        </c:scaling>
+        <c:delete val="0"/>
+        <c:axPos val="b"/>
+        <c:majorGridlines>
+          <c:spPr>
+            <a:ln w="9525" cap="flat">
+              <a:solidFill>
+                <a:srgbClr val="E5E5EF"/>
+              </a:solidFill>
+              <a:prstDash val="solid"/>
+              <a:round/>
+            </a:ln>
+          </c:spPr>
+        </c:majorGridlines>
+        <c:numFmt formatCode="General" sourceLinked="0"/>
+        <c:majorTickMark val="out"/>
+        <c:minorTickMark val="none"/>
+        <c:tickLblPos val="low"/>
+        <c:spPr>
+          <a:ln w="12700" cap="flat">
+            <a:solidFill>
+              <a:srgbClr val="888888"/>
+            </a:solidFill>
+            <a:prstDash val="solid"/>
+            <a:round/>
+          </a:ln>
+        </c:spPr>
+        <c:txPr>
+          <a:bodyPr/>
+          <a:lstStyle/>
+          <a:p>
+            <a:pPr>
+              <a:defRPr sz="850" b="0" i="0" u="none" strike="noStrike">
+                <a:solidFill>
+                  <a:srgbClr val="5B6178"/>
+                </a:solidFill>
+                <a:latin typeface="Arial"/>
+              </a:defRPr>
+            </a:pPr>
+            <a:endParaRPr lang="en-US"/>
+          </a:p>
+        </c:txPr>
+        <c:crossAx val="2094734554"/>
+        <c:crosses val="autoZero"/>
+        <c:crossBetween val="between"/>
+      </c:valAx>
+      <c:spPr>
+        <a:noFill/>
+        <a:ln>
+          <a:noFill/>
+        </a:ln>
+        <a:effectLst/>
+      </c:spPr>
+    </c:plotArea>
+    <c:plotVisOnly val="1"/>
+    <c:dispBlanksAs val="span"/>
+  </c:chart>
+  <c:spPr>
+    <a:noFill/>
+    <a:ln>
+      <a:noFill/>
+    </a:ln>
+    <a:effectLst/>
+  </c:spPr>
+  <c:externalData r:id="rId1">
+    <c:autoUpdate val="0"/>
+  </c:externalData>
+</c:chartSpace>
+</file>
+
 <file path=ppt/notesMasters/notesMaster1.xml><?xml version="1.0" encoding="utf-8"?>
 <p:notesMaster xmlns:a="http://schemas.openxmlformats.org/drawingml/2006/main" xmlns:r="http://schemas.openxmlformats.org/officeDocument/2006/relationships" xmlns:p="http://schemas.openxmlformats.org/presentationml/2006/main">
   <p:cSld>
@@ -2181,6 +2457,94 @@
             <a:fld id="{F7021451-1387-4CA6-816F-3879F97B5CBC}" type="slidenum">
               <a:rPr lang="en-US"/>
               <a:t>11</a:t>
+            </a:fld>
+            <a:endParaRPr lang="en-US"/>
+          </a:p>
+        </p:txBody>
+      </p:sp>
+    </p:spTree>
+    <p:extLst>
+      <p:ext uri="{BB962C8B-B14F-4D97-AF65-F5344CB8AC3E}">
+        <p14:creationId xmlns:p14="http://schemas.microsoft.com/office/powerpoint/2010/main" val="1024086991"/>
+      </p:ext>
+    </p:extLst>
+  </p:cSld>
+  <p:clrMapOvr>
+    <a:masterClrMapping/>
+  </p:clrMapOvr>
+</p:notes>
+</file>
+
+<file path=ppt/notesSlides/notesSlide12.xml><?xml version="1.0" encoding="utf-8"?>
+<p:notes xmlns:a="http://schemas.openxmlformats.org/drawingml/2006/main" xmlns:r="http://schemas.openxmlformats.org/officeDocument/2006/relationships" xmlns:p="http://schemas.openxmlformats.org/presentationml/2006/main">
+  <p:cSld>
+    <p:spTree>
+      <p:nvGrpSpPr>
+        <p:cNvPr id="1" name=""/>
+        <p:cNvGrpSpPr/>
+        <p:nvPr/>
+      </p:nvGrpSpPr>
+      <p:grpSpPr>
+        <a:xfrm>
+          <a:off x="0" y="0"/>
+          <a:ext cx="0" cy="0"/>
+          <a:chOff x="0" y="0"/>
+          <a:chExt cx="0" cy="0"/>
+        </a:xfrm>
+      </p:grpSpPr>
+      <p:sp>
+        <p:nvSpPr>
+          <p:cNvPr id="2" name="Slide Image Placeholder 1"/>
+          <p:cNvSpPr>
+            <a:spLocks noGrp="1" noRot="1" noChangeAspect="1"/>
+          </p:cNvSpPr>
+          <p:nvPr>
+            <p:ph type="sldImg"/>
+          </p:nvPr>
+        </p:nvSpPr>
+        <p:spPr/>
+      </p:sp>
+      <p:sp>
+        <p:nvSpPr>
+          <p:cNvPr id="3" name="Notes Placeholder 2"/>
+          <p:cNvSpPr>
+            <a:spLocks noGrp="1"/>
+          </p:cNvSpPr>
+          <p:nvPr>
+            <p:ph type="body" idx="1"/>
+          </p:nvPr>
+        </p:nvSpPr>
+        <p:spPr/>
+        <p:txBody>
+          <a:bodyPr/>
+          <a:lstStyle/>
+          <a:p>
+            <a:r>
+              <a:rPr lang="en-US" dirty="0"/>
+              <a:t/>
+            </a:r>
+            <a:endParaRPr lang="en-US" dirty="0"/>
+          </a:p>
+        </p:txBody>
+      </p:sp>
+      <p:sp>
+        <p:nvSpPr>
+          <p:cNvPr id="4" name="Slide Number Placeholder 3"/>
+          <p:cNvSpPr>
+            <a:spLocks noGrp="1"/>
+          </p:cNvSpPr>
+          <p:nvPr>
+            <p:ph type="sldNum" sz="quarter" idx="10"/>
+          </p:nvPr>
+        </p:nvSpPr>
+        <p:spPr/>
+        <p:txBody>
+          <a:bodyPr/>
+          <a:lstStyle/>
+          <a:p>
+            <a:fld id="{F7021451-1387-4CA6-816F-3879F97B5CBC}" type="slidenum">
+              <a:rPr lang="en-US"/>
+              <a:t>12</a:t>
             </a:fld>
             <a:endParaRPr lang="en-US"/>
           </a:p>
@@ -3388,7 +3752,7 @@
                 <a:ea typeface="Calibri" pitchFamily="34" charset="-122"/>
                 <a:cs typeface="Calibri" pitchFamily="34" charset="-120"/>
               </a:rPr>
-              <a:t>A causal measurement framework, calibrated media-mix model, and budget optimizer — built to answer the two questions Atmosphere's advertising business runs on.</a:t>
+              <a:t>A causal measurement framework, calibrated media-mix model, budget optimizer, and venue-revenue model — built to answer the questions Atmosphere's advertising business and its own network economics run on.</a:t>
             </a:r>
             <a:endParaRPr lang="en-US" sz="1500" dirty="0"/>
           </a:p>
@@ -3493,24 +3857,24 @@
         </p:nvSpPr>
         <p:spPr>
           <a:xfrm>
-            <a:off x="548640" y="457200"/>
-            <a:ext cx="7315200" cy="640080"/>
-          </a:xfrm>
-          <a:prstGeom prst="rect">
-            <a:avLst/>
-          </a:prstGeom>
-          <a:noFill/>
-          <a:ln/>
-        </p:spPr>
-        <p:txBody>
-          <a:bodyPr wrap="square" rtlCol="0" anchor="ctr"/>
-          <a:lstStyle/>
-          <a:p>
-            <a:pPr indent="0" marL="0">
-              <a:buNone/>
-            </a:pPr>
-            <a:r>
-              <a:rPr lang="en-US" sz="3000" b="1" dirty="0">
+            <a:off x="548640" y="411480"/>
+            <a:ext cx="11155680" cy="594360"/>
+          </a:xfrm>
+          <a:prstGeom prst="rect">
+            <a:avLst/>
+          </a:prstGeom>
+          <a:noFill/>
+          <a:ln/>
+        </p:spPr>
+        <p:txBody>
+          <a:bodyPr wrap="square" rtlCol="0" anchor="ctr"/>
+          <a:lstStyle/>
+          <a:p>
+            <a:pPr indent="0" marL="0">
+              <a:buNone/>
+            </a:pPr>
+            <a:r>
+              <a:rPr lang="en-US" sz="2500" b="1" dirty="0">
                 <a:solidFill>
                   <a:srgbClr val="1E2761"/>
                 </a:solidFill>
@@ -3518,58 +3882,99 @@
                 <a:ea typeface="Cambria" pitchFamily="34" charset="-122"/>
                 <a:cs typeface="Cambria" pitchFamily="34" charset="-120"/>
               </a:rPr>
-              <a:t>Honest scope</a:t>
-            </a:r>
-            <a:endParaRPr lang="en-US" sz="3000" dirty="0"/>
-          </a:p>
-        </p:txBody>
-      </p:sp>
-      <p:sp>
-        <p:nvSpPr>
-          <p:cNvPr id="3" name="Shape 1"/>
-          <p:cNvSpPr/>
-          <p:nvPr/>
-        </p:nvSpPr>
-        <p:spPr>
-          <a:xfrm>
-            <a:off x="548640" y="1426464"/>
-            <a:ext cx="109728" cy="960120"/>
-          </a:xfrm>
-          <a:prstGeom prst="rect">
-            <a:avLst/>
+              <a:t>Phase 2: predicting venue ad-revenue, honestly</a:t>
+            </a:r>
+            <a:endParaRPr lang="en-US" sz="2500" dirty="0"/>
+          </a:p>
+        </p:txBody>
+      </p:sp>
+      <p:sp>
+        <p:nvSpPr>
+          <p:cNvPr id="3" name="Text 1"/>
+          <p:cNvSpPr/>
+          <p:nvPr/>
+        </p:nvSpPr>
+        <p:spPr>
+          <a:xfrm>
+            <a:off x="548640" y="1005840"/>
+            <a:ext cx="10972800" cy="365760"/>
+          </a:xfrm>
+          <a:prstGeom prst="rect">
+            <a:avLst/>
+          </a:prstGeom>
+          <a:noFill/>
+          <a:ln/>
+        </p:spPr>
+        <p:txBody>
+          <a:bodyPr wrap="square" rtlCol="0" anchor="ctr"/>
+          <a:lstStyle/>
+          <a:p>
+            <a:pPr indent="0" marL="0">
+              <a:buNone/>
+            </a:pPr>
+            <a:r>
+              <a:rPr lang="en-US" sz="1250" i="1" dirty="0">
+                <a:solidFill>
+                  <a:srgbClr val="5B6178"/>
+                </a:solidFill>
+                <a:latin typeface="Calibri" pitchFamily="34" charset="0"/>
+                <a:ea typeface="Calibri" pitchFamily="34" charset="-122"/>
+                <a:cs typeface="Calibri" pitchFamily="34" charset="-120"/>
+              </a:rPr>
+              <a:t>Gradient-boosted trees on observable venue characteristics + Phase 1's calibrated per-exposure lift as a feature.</a:t>
+            </a:r>
+            <a:endParaRPr lang="en-US" sz="1250" dirty="0"/>
+          </a:p>
+        </p:txBody>
+      </p:sp>
+      <p:sp>
+        <p:nvSpPr>
+          <p:cNvPr id="4" name="Shape 2"/>
+          <p:cNvSpPr/>
+          <p:nvPr/>
+        </p:nvSpPr>
+        <p:spPr>
+          <a:xfrm>
+            <a:off x="548640" y="1508760"/>
+            <a:ext cx="2651760" cy="1051560"/>
+          </a:xfrm>
+          <a:prstGeom prst="roundRect">
+            <a:avLst>
+              <a:gd name="adj" fmla="val 6957"/>
+            </a:avLst>
           </a:prstGeom>
           <a:solidFill>
-            <a:srgbClr val="E8871E"/>
+            <a:srgbClr val="F5F7FC"/>
           </a:solidFill>
           <a:ln/>
         </p:spPr>
       </p:sp>
       <p:sp>
         <p:nvSpPr>
-          <p:cNvPr id="4" name="Text 2"/>
-          <p:cNvSpPr/>
-          <p:nvPr/>
-        </p:nvSpPr>
-        <p:spPr>
-          <a:xfrm>
-            <a:off x="868680" y="1371600"/>
-            <a:ext cx="2743200" cy="1097280"/>
-          </a:xfrm>
-          <a:prstGeom prst="rect">
-            <a:avLst/>
-          </a:prstGeom>
-          <a:noFill/>
-          <a:ln/>
-        </p:spPr>
-        <p:txBody>
-          <a:bodyPr wrap="square" rtlCol="0" anchor="t"/>
-          <a:lstStyle/>
-          <a:p>
-            <a:pPr indent="0" marL="0">
-              <a:buNone/>
-            </a:pPr>
-            <a:r>
-              <a:rPr lang="en-US" sz="1350" b="1" dirty="0">
+          <p:cNvPr id="5" name="Text 3"/>
+          <p:cNvSpPr/>
+          <p:nvPr/>
+        </p:nvSpPr>
+        <p:spPr>
+          <a:xfrm>
+            <a:off x="685800" y="1618488"/>
+            <a:ext cx="2377440" cy="502920"/>
+          </a:xfrm>
+          <a:prstGeom prst="rect">
+            <a:avLst/>
+          </a:prstGeom>
+          <a:noFill/>
+          <a:ln/>
+        </p:spPr>
+        <p:txBody>
+          <a:bodyPr wrap="square" rtlCol="0" anchor="ctr"/>
+          <a:lstStyle/>
+          <a:p>
+            <a:pPr indent="0" marL="0">
+              <a:buNone/>
+            </a:pPr>
+            <a:r>
+              <a:rPr lang="en-US" sz="2200" b="1" dirty="0">
                 <a:solidFill>
                   <a:srgbClr val="1E2761"/>
                 </a:solidFill>
@@ -3577,360 +3982,1114 @@
                 <a:ea typeface="Calibri" pitchFamily="34" charset="-122"/>
                 <a:cs typeface="Calibri" pitchFamily="34" charset="-120"/>
               </a:rPr>
-              <a:t>Synthetic data</a:t>
-            </a:r>
-            <a:endParaRPr lang="en-US" sz="1350" dirty="0"/>
-          </a:p>
-        </p:txBody>
-      </p:sp>
-      <p:sp>
-        <p:nvSpPr>
-          <p:cNvPr id="5" name="Text 3"/>
-          <p:cNvSpPr/>
-          <p:nvPr/>
-        </p:nvSpPr>
-        <p:spPr>
-          <a:xfrm>
-            <a:off x="3794760" y="1371600"/>
-            <a:ext cx="7863840" cy="1097280"/>
-          </a:xfrm>
-          <a:prstGeom prst="rect">
-            <a:avLst/>
-          </a:prstGeom>
-          <a:noFill/>
-          <a:ln/>
-        </p:spPr>
-        <p:txBody>
-          <a:bodyPr wrap="square" rtlCol="0" anchor="t"/>
+              <a:t>0.84</a:t>
+            </a:r>
+            <a:endParaRPr lang="en-US" sz="2200" dirty="0"/>
+          </a:p>
+        </p:txBody>
+      </p:sp>
+      <p:sp>
+        <p:nvSpPr>
+          <p:cNvPr id="6" name="Text 4"/>
+          <p:cNvSpPr/>
+          <p:nvPr/>
+        </p:nvSpPr>
+        <p:spPr>
+          <a:xfrm>
+            <a:off x="685800" y="2130552"/>
+            <a:ext cx="2377440" cy="365760"/>
+          </a:xfrm>
+          <a:prstGeom prst="rect">
+            <a:avLst/>
+          </a:prstGeom>
+          <a:noFill/>
+          <a:ln/>
+        </p:spPr>
+        <p:txBody>
+          <a:bodyPr wrap="square" rtlCol="0" anchor="ctr"/>
+          <a:lstStyle/>
+          <a:p>
+            <a:pPr indent="0" marL="0">
+              <a:buNone/>
+            </a:pPr>
+            <a:r>
+              <a:rPr lang="en-US" sz="950" dirty="0">
+                <a:solidFill>
+                  <a:srgbClr val="5B6178"/>
+                </a:solidFill>
+                <a:latin typeface="Calibri" pitchFamily="34" charset="0"/>
+                <a:ea typeface="Calibri" pitchFamily="34" charset="-122"/>
+                <a:cs typeface="Calibri" pitchFamily="34" charset="-120"/>
+              </a:rPr>
+              <a:t>Held-out R²</a:t>
+            </a:r>
+            <a:endParaRPr lang="en-US" sz="950" dirty="0"/>
+          </a:p>
+        </p:txBody>
+      </p:sp>
+      <p:sp>
+        <p:nvSpPr>
+          <p:cNvPr id="7" name="Shape 5"/>
+          <p:cNvSpPr/>
+          <p:nvPr/>
+        </p:nvSpPr>
+        <p:spPr>
+          <a:xfrm>
+            <a:off x="3337560" y="1508760"/>
+            <a:ext cx="2651760" cy="1051560"/>
+          </a:xfrm>
+          <a:prstGeom prst="roundRect">
+            <a:avLst>
+              <a:gd name="adj" fmla="val 6957"/>
+            </a:avLst>
+          </a:prstGeom>
+          <a:solidFill>
+            <a:srgbClr val="F5F7FC"/>
+          </a:solidFill>
+          <a:ln/>
+        </p:spPr>
+      </p:sp>
+      <p:sp>
+        <p:nvSpPr>
+          <p:cNvPr id="8" name="Text 6"/>
+          <p:cNvSpPr/>
+          <p:nvPr/>
+        </p:nvSpPr>
+        <p:spPr>
+          <a:xfrm>
+            <a:off x="3474720" y="1618488"/>
+            <a:ext cx="2377440" cy="502920"/>
+          </a:xfrm>
+          <a:prstGeom prst="rect">
+            <a:avLst/>
+          </a:prstGeom>
+          <a:noFill/>
+          <a:ln/>
+        </p:spPr>
+        <p:txBody>
+          <a:bodyPr wrap="square" rtlCol="0" anchor="ctr"/>
+          <a:lstStyle/>
+          <a:p>
+            <a:pPr indent="0" marL="0">
+              <a:buNone/>
+            </a:pPr>
+            <a:r>
+              <a:rPr lang="en-US" sz="2200" b="1" dirty="0">
+                <a:solidFill>
+                  <a:srgbClr val="1E2761"/>
+                </a:solidFill>
+                <a:latin typeface="Calibri" pitchFamily="34" charset="0"/>
+                <a:ea typeface="Calibri" pitchFamily="34" charset="-122"/>
+                <a:cs typeface="Calibri" pitchFamily="34" charset="-120"/>
+              </a:rPr>
+              <a:t>22.1%</a:t>
+            </a:r>
+            <a:endParaRPr lang="en-US" sz="2200" dirty="0"/>
+          </a:p>
+        </p:txBody>
+      </p:sp>
+      <p:sp>
+        <p:nvSpPr>
+          <p:cNvPr id="9" name="Text 7"/>
+          <p:cNvSpPr/>
+          <p:nvPr/>
+        </p:nvSpPr>
+        <p:spPr>
+          <a:xfrm>
+            <a:off x="3474720" y="2130552"/>
+            <a:ext cx="2377440" cy="365760"/>
+          </a:xfrm>
+          <a:prstGeom prst="rect">
+            <a:avLst/>
+          </a:prstGeom>
+          <a:noFill/>
+          <a:ln/>
+        </p:spPr>
+        <p:txBody>
+          <a:bodyPr wrap="square" rtlCol="0" anchor="ctr"/>
+          <a:lstStyle/>
+          <a:p>
+            <a:pPr indent="0" marL="0">
+              <a:buNone/>
+            </a:pPr>
+            <a:r>
+              <a:rPr lang="en-US" sz="950" dirty="0">
+                <a:solidFill>
+                  <a:srgbClr val="5B6178"/>
+                </a:solidFill>
+                <a:latin typeface="Calibri" pitchFamily="34" charset="0"/>
+                <a:ea typeface="Calibri" pitchFamily="34" charset="-122"/>
+                <a:cs typeface="Calibri" pitchFamily="34" charset="-120"/>
+              </a:rPr>
+              <a:t>Held-out MAPE</a:t>
+            </a:r>
+            <a:endParaRPr lang="en-US" sz="950" dirty="0"/>
+          </a:p>
+        </p:txBody>
+      </p:sp>
+      <p:sp>
+        <p:nvSpPr>
+          <p:cNvPr id="10" name="Shape 8"/>
+          <p:cNvSpPr/>
+          <p:nvPr/>
+        </p:nvSpPr>
+        <p:spPr>
+          <a:xfrm>
+            <a:off x="6126480" y="1508760"/>
+            <a:ext cx="2651760" cy="1051560"/>
+          </a:xfrm>
+          <a:prstGeom prst="roundRect">
+            <a:avLst>
+              <a:gd name="adj" fmla="val 6957"/>
+            </a:avLst>
+          </a:prstGeom>
+          <a:solidFill>
+            <a:srgbClr val="F5F7FC"/>
+          </a:solidFill>
+          <a:ln/>
+        </p:spPr>
+      </p:sp>
+      <p:sp>
+        <p:nvSpPr>
+          <p:cNvPr id="11" name="Text 9"/>
+          <p:cNvSpPr/>
+          <p:nvPr/>
+        </p:nvSpPr>
+        <p:spPr>
+          <a:xfrm>
+            <a:off x="6263640" y="1618488"/>
+            <a:ext cx="2377440" cy="502920"/>
+          </a:xfrm>
+          <a:prstGeom prst="rect">
+            <a:avLst/>
+          </a:prstGeom>
+          <a:noFill/>
+          <a:ln/>
+        </p:spPr>
+        <p:txBody>
+          <a:bodyPr wrap="square" rtlCol="0" anchor="ctr"/>
+          <a:lstStyle/>
+          <a:p>
+            <a:pPr indent="0" marL="0">
+              <a:buNone/>
+            </a:pPr>
+            <a:r>
+              <a:rPr lang="en-US" sz="2200" b="1" dirty="0">
+                <a:solidFill>
+                  <a:srgbClr val="1E2761"/>
+                </a:solidFill>
+                <a:latin typeface="Calibri" pitchFamily="34" charset="0"/>
+                <a:ea typeface="Calibri" pitchFamily="34" charset="-122"/>
+                <a:cs typeface="Calibri" pitchFamily="34" charset="-120"/>
+              </a:rPr>
+              <a:t>0.94</a:t>
+            </a:r>
+            <a:endParaRPr lang="en-US" sz="2200" dirty="0"/>
+          </a:p>
+        </p:txBody>
+      </p:sp>
+      <p:sp>
+        <p:nvSpPr>
+          <p:cNvPr id="12" name="Text 10"/>
+          <p:cNvSpPr/>
+          <p:nvPr/>
+        </p:nvSpPr>
+        <p:spPr>
+          <a:xfrm>
+            <a:off x="6263640" y="2130552"/>
+            <a:ext cx="2377440" cy="365760"/>
+          </a:xfrm>
+          <a:prstGeom prst="rect">
+            <a:avLst/>
+          </a:prstGeom>
+          <a:noFill/>
+          <a:ln/>
+        </p:spPr>
+        <p:txBody>
+          <a:bodyPr wrap="square" rtlCol="0" anchor="ctr"/>
+          <a:lstStyle/>
+          <a:p>
+            <a:pPr indent="0" marL="0">
+              <a:buNone/>
+            </a:pPr>
+            <a:r>
+              <a:rPr lang="en-US" sz="950" dirty="0">
+                <a:solidFill>
+                  <a:srgbClr val="5B6178"/>
+                </a:solidFill>
+                <a:latin typeface="Calibri" pitchFamily="34" charset="0"/>
+                <a:ea typeface="Calibri" pitchFamily="34" charset="-122"/>
+                <a:cs typeface="Calibri" pitchFamily="34" charset="-120"/>
+              </a:rPr>
+              <a:t>Corr. w/ latent true potential</a:t>
+            </a:r>
+            <a:endParaRPr lang="en-US" sz="950" dirty="0"/>
+          </a:p>
+        </p:txBody>
+      </p:sp>
+      <p:sp>
+        <p:nvSpPr>
+          <p:cNvPr id="13" name="Shape 11"/>
+          <p:cNvSpPr/>
+          <p:nvPr/>
+        </p:nvSpPr>
+        <p:spPr>
+          <a:xfrm>
+            <a:off x="8915400" y="1508760"/>
+            <a:ext cx="2651760" cy="1051560"/>
+          </a:xfrm>
+          <a:prstGeom prst="roundRect">
+            <a:avLst>
+              <a:gd name="adj" fmla="val 6957"/>
+            </a:avLst>
+          </a:prstGeom>
+          <a:solidFill>
+            <a:srgbClr val="F5F7FC"/>
+          </a:solidFill>
+          <a:ln/>
+        </p:spPr>
+      </p:sp>
+      <p:sp>
+        <p:nvSpPr>
+          <p:cNvPr id="14" name="Text 12"/>
+          <p:cNvSpPr/>
+          <p:nvPr/>
+        </p:nvSpPr>
+        <p:spPr>
+          <a:xfrm>
+            <a:off x="9052560" y="1618488"/>
+            <a:ext cx="2377440" cy="502920"/>
+          </a:xfrm>
+          <a:prstGeom prst="rect">
+            <a:avLst/>
+          </a:prstGeom>
+          <a:noFill/>
+          <a:ln/>
+        </p:spPr>
+        <p:txBody>
+          <a:bodyPr wrap="square" rtlCol="0" anchor="ctr"/>
+          <a:lstStyle/>
+          <a:p>
+            <a:pPr indent="0" marL="0">
+              <a:buNone/>
+            </a:pPr>
+            <a:r>
+              <a:rPr lang="en-US" sz="2200" b="1" dirty="0">
+                <a:solidFill>
+                  <a:srgbClr val="1E2761"/>
+                </a:solidFill>
+                <a:latin typeface="Calibri" pitchFamily="34" charset="0"/>
+                <a:ea typeface="Calibri" pitchFamily="34" charset="-122"/>
+                <a:cs typeface="Calibri" pitchFamily="34" charset="-120"/>
+              </a:rPr>
+              <a:t>90% vs 28%</a:t>
+            </a:r>
+            <a:endParaRPr lang="en-US" sz="2200" dirty="0"/>
+          </a:p>
+        </p:txBody>
+      </p:sp>
+      <p:sp>
+        <p:nvSpPr>
+          <p:cNvPr id="15" name="Text 13"/>
+          <p:cNvSpPr/>
+          <p:nvPr/>
+        </p:nvSpPr>
+        <p:spPr>
+          <a:xfrm>
+            <a:off x="9052560" y="2130552"/>
+            <a:ext cx="2377440" cy="365760"/>
+          </a:xfrm>
+          <a:prstGeom prst="rect">
+            <a:avLst/>
+          </a:prstGeom>
+          <a:noFill/>
+          <a:ln/>
+        </p:spPr>
+        <p:txBody>
+          <a:bodyPr wrap="square" rtlCol="0" anchor="ctr"/>
+          <a:lstStyle/>
+          <a:p>
+            <a:pPr indent="0" marL="0">
+              <a:buNone/>
+            </a:pPr>
+            <a:r>
+              <a:rPr lang="en-US" sz="950" dirty="0">
+                <a:solidFill>
+                  <a:srgbClr val="5B6178"/>
+                </a:solidFill>
+                <a:latin typeface="Calibri" pitchFamily="34" charset="0"/>
+                <a:ea typeface="Calibri" pitchFamily="34" charset="-122"/>
+                <a:cs typeface="Calibri" pitchFamily="34" charset="-120"/>
+              </a:rPr>
+              <a:t>Flagged-tail latent gap rate</a:t>
+            </a:r>
+            <a:endParaRPr lang="en-US" sz="950" dirty="0"/>
+          </a:p>
+        </p:txBody>
+      </p:sp>
+      <p:graphicFrame>
+        <p:nvGraphicFramePr>
+          <p:cNvPr id="16" name="Chart 0" descr=""/>
+          <p:cNvGraphicFramePr/>
+          <p:nvPr/>
+        </p:nvGraphicFramePr>
+        <p:xfrm>
+          <a:off x="548640" y="2880360"/>
+          <a:ext cx="5394960" cy="3246120"/>
+        </p:xfrm>
+        <a:graphic xmlns:a="http://schemas.openxmlformats.org/drawingml/2006/main">
+          <a:graphicData uri="http://schemas.openxmlformats.org/drawingml/2006/chart">
+            <c:chart xmlns:c="http://schemas.openxmlformats.org/drawingml/2006/chart" r:id="rId1"/>
+          </a:graphicData>
+        </a:graphic>
+      </p:graphicFrame>
+      <p:sp>
+        <p:nvSpPr>
+          <p:cNvPr id="17" name="Text 14"/>
+          <p:cNvSpPr/>
+          <p:nvPr/>
+        </p:nvSpPr>
+        <p:spPr>
+          <a:xfrm>
+            <a:off x="6263640" y="2880360"/>
+            <a:ext cx="5394960" cy="274320"/>
+          </a:xfrm>
+          <a:prstGeom prst="rect">
+            <a:avLst/>
+          </a:prstGeom>
+          <a:noFill/>
+          <a:ln/>
+        </p:spPr>
+        <p:txBody>
+          <a:bodyPr wrap="square" rtlCol="0" anchor="ctr"/>
+          <a:lstStyle/>
+          <a:p>
+            <a:pPr indent="0" marL="0">
+              <a:buNone/>
+            </a:pPr>
+            <a:r>
+              <a:rPr lang="en-US" sz="1200" b="1" dirty="0">
+                <a:solidFill>
+                  <a:srgbClr val="1E2761"/>
+                </a:solidFill>
+                <a:latin typeface="Cambria" pitchFamily="34" charset="0"/>
+                <a:ea typeface="Cambria" pitchFamily="34" charset="-122"/>
+                <a:cs typeface="Cambria" pitchFamily="34" charset="-120"/>
+              </a:rPr>
+              <a:t>Top under-monetized venues (of 20 flagged)</a:t>
+            </a:r>
+            <a:endParaRPr lang="en-US" sz="1200" dirty="0"/>
+          </a:p>
+        </p:txBody>
+      </p:sp>
+      <p:sp>
+        <p:nvSpPr>
+          <p:cNvPr id="18" name="Text 15"/>
+          <p:cNvSpPr/>
+          <p:nvPr/>
+        </p:nvSpPr>
+        <p:spPr>
+          <a:xfrm>
+            <a:off x="6263640" y="3209544"/>
+            <a:ext cx="3657600" cy="274320"/>
+          </a:xfrm>
+          <a:prstGeom prst="rect">
+            <a:avLst/>
+          </a:prstGeom>
+          <a:noFill/>
+          <a:ln/>
+        </p:spPr>
+        <p:txBody>
+          <a:bodyPr wrap="square" rtlCol="0" anchor="ctr"/>
+          <a:lstStyle/>
+          <a:p>
+            <a:pPr indent="0" marL="0">
+              <a:buNone/>
+            </a:pPr>
+            <a:r>
+              <a:rPr lang="en-US" sz="1000" dirty="0">
+                <a:solidFill>
+                  <a:srgbClr val="1A1A2E"/>
+                </a:solidFill>
+                <a:latin typeface="Calibri" pitchFamily="34" charset="0"/>
+                <a:ea typeface="Calibri" pitchFamily="34" charset="-122"/>
+                <a:cs typeface="Calibri" pitchFamily="34" charset="-120"/>
+              </a:rPr>
+              <a:t>Venue #85 (Restaurants)</a:t>
+            </a:r>
+            <a:endParaRPr lang="en-US" sz="1000" dirty="0"/>
+          </a:p>
+        </p:txBody>
+      </p:sp>
+      <p:sp>
+        <p:nvSpPr>
+          <p:cNvPr id="19" name="Text 16"/>
+          <p:cNvSpPr/>
+          <p:nvPr/>
+        </p:nvSpPr>
+        <p:spPr>
+          <a:xfrm>
+            <a:off x="9966960" y="3209544"/>
+            <a:ext cx="1691640" cy="274320"/>
+          </a:xfrm>
+          <a:prstGeom prst="rect">
+            <a:avLst/>
+          </a:prstGeom>
+          <a:noFill/>
+          <a:ln/>
+        </p:spPr>
+        <p:txBody>
+          <a:bodyPr wrap="square" rtlCol="0" anchor="ctr"/>
+          <a:lstStyle/>
+          <a:p>
+            <a:pPr algn="r" indent="0" marL="0">
+              <a:buNone/>
+            </a:pPr>
+            <a:r>
+              <a:rPr lang="en-US" sz="1000" b="1" dirty="0">
+                <a:solidFill>
+                  <a:srgbClr val="B8500A"/>
+                </a:solidFill>
+                <a:latin typeface="Calibri" pitchFamily="34" charset="0"/>
+                <a:ea typeface="Calibri" pitchFamily="34" charset="-122"/>
+                <a:cs typeface="Calibri" pitchFamily="34" charset="-120"/>
+              </a:rPr>
+              <a:t>-62%</a:t>
+            </a:r>
+            <a:endParaRPr lang="en-US" sz="1000" dirty="0"/>
+          </a:p>
+        </p:txBody>
+      </p:sp>
+      <p:sp>
+        <p:nvSpPr>
+          <p:cNvPr id="20" name="Text 17"/>
+          <p:cNvSpPr/>
+          <p:nvPr/>
+        </p:nvSpPr>
+        <p:spPr>
+          <a:xfrm>
+            <a:off x="6263640" y="3502152"/>
+            <a:ext cx="3657600" cy="274320"/>
+          </a:xfrm>
+          <a:prstGeom prst="rect">
+            <a:avLst/>
+          </a:prstGeom>
+          <a:noFill/>
+          <a:ln/>
+        </p:spPr>
+        <p:txBody>
+          <a:bodyPr wrap="square" rtlCol="0" anchor="ctr"/>
+          <a:lstStyle/>
+          <a:p>
+            <a:pPr indent="0" marL="0">
+              <a:buNone/>
+            </a:pPr>
+            <a:r>
+              <a:rPr lang="en-US" sz="1000" dirty="0">
+                <a:solidFill>
+                  <a:srgbClr val="1A1A2E"/>
+                </a:solidFill>
+                <a:latin typeface="Calibri" pitchFamily="34" charset="0"/>
+                <a:ea typeface="Calibri" pitchFamily="34" charset="-122"/>
+                <a:cs typeface="Calibri" pitchFamily="34" charset="-120"/>
+              </a:rPr>
+              <a:t>Venue #309 (Waiting Rooms)</a:t>
+            </a:r>
+            <a:endParaRPr lang="en-US" sz="1000" dirty="0"/>
+          </a:p>
+        </p:txBody>
+      </p:sp>
+      <p:sp>
+        <p:nvSpPr>
+          <p:cNvPr id="21" name="Text 18"/>
+          <p:cNvSpPr/>
+          <p:nvPr/>
+        </p:nvSpPr>
+        <p:spPr>
+          <a:xfrm>
+            <a:off x="9966960" y="3502152"/>
+            <a:ext cx="1691640" cy="274320"/>
+          </a:xfrm>
+          <a:prstGeom prst="rect">
+            <a:avLst/>
+          </a:prstGeom>
+          <a:noFill/>
+          <a:ln/>
+        </p:spPr>
+        <p:txBody>
+          <a:bodyPr wrap="square" rtlCol="0" anchor="ctr"/>
+          <a:lstStyle/>
+          <a:p>
+            <a:pPr algn="r" indent="0" marL="0">
+              <a:buNone/>
+            </a:pPr>
+            <a:r>
+              <a:rPr lang="en-US" sz="1000" b="1" dirty="0">
+                <a:solidFill>
+                  <a:srgbClr val="B8500A"/>
+                </a:solidFill>
+                <a:latin typeface="Calibri" pitchFamily="34" charset="0"/>
+                <a:ea typeface="Calibri" pitchFamily="34" charset="-122"/>
+                <a:cs typeface="Calibri" pitchFamily="34" charset="-120"/>
+              </a:rPr>
+              <a:t>-61%</a:t>
+            </a:r>
+            <a:endParaRPr lang="en-US" sz="1000" dirty="0"/>
+          </a:p>
+        </p:txBody>
+      </p:sp>
+      <p:sp>
+        <p:nvSpPr>
+          <p:cNvPr id="22" name="Text 19"/>
+          <p:cNvSpPr/>
+          <p:nvPr/>
+        </p:nvSpPr>
+        <p:spPr>
+          <a:xfrm>
+            <a:off x="6263640" y="3794760"/>
+            <a:ext cx="3657600" cy="274320"/>
+          </a:xfrm>
+          <a:prstGeom prst="rect">
+            <a:avLst/>
+          </a:prstGeom>
+          <a:noFill/>
+          <a:ln/>
+        </p:spPr>
+        <p:txBody>
+          <a:bodyPr wrap="square" rtlCol="0" anchor="ctr"/>
+          <a:lstStyle/>
+          <a:p>
+            <a:pPr indent="0" marL="0">
+              <a:buNone/>
+            </a:pPr>
+            <a:r>
+              <a:rPr lang="en-US" sz="1000" dirty="0">
+                <a:solidFill>
+                  <a:srgbClr val="1A1A2E"/>
+                </a:solidFill>
+                <a:latin typeface="Calibri" pitchFamily="34" charset="0"/>
+                <a:ea typeface="Calibri" pitchFamily="34" charset="-122"/>
+                <a:cs typeface="Calibri" pitchFamily="34" charset="-120"/>
+              </a:rPr>
+              <a:t>Venue #53 (Restaurants)</a:t>
+            </a:r>
+            <a:endParaRPr lang="en-US" sz="1000" dirty="0"/>
+          </a:p>
+        </p:txBody>
+      </p:sp>
+      <p:sp>
+        <p:nvSpPr>
+          <p:cNvPr id="23" name="Text 20"/>
+          <p:cNvSpPr/>
+          <p:nvPr/>
+        </p:nvSpPr>
+        <p:spPr>
+          <a:xfrm>
+            <a:off x="9966960" y="3794760"/>
+            <a:ext cx="1691640" cy="274320"/>
+          </a:xfrm>
+          <a:prstGeom prst="rect">
+            <a:avLst/>
+          </a:prstGeom>
+          <a:noFill/>
+          <a:ln/>
+        </p:spPr>
+        <p:txBody>
+          <a:bodyPr wrap="square" rtlCol="0" anchor="ctr"/>
+          <a:lstStyle/>
+          <a:p>
+            <a:pPr algn="r" indent="0" marL="0">
+              <a:buNone/>
+            </a:pPr>
+            <a:r>
+              <a:rPr lang="en-US" sz="1000" b="1" dirty="0">
+                <a:solidFill>
+                  <a:srgbClr val="B8500A"/>
+                </a:solidFill>
+                <a:latin typeface="Calibri" pitchFamily="34" charset="0"/>
+                <a:ea typeface="Calibri" pitchFamily="34" charset="-122"/>
+                <a:cs typeface="Calibri" pitchFamily="34" charset="-120"/>
+              </a:rPr>
+              <a:t>-61%</a:t>
+            </a:r>
+            <a:endParaRPr lang="en-US" sz="1000" dirty="0"/>
+          </a:p>
+        </p:txBody>
+      </p:sp>
+      <p:sp>
+        <p:nvSpPr>
+          <p:cNvPr id="24" name="Text 21"/>
+          <p:cNvSpPr/>
+          <p:nvPr/>
+        </p:nvSpPr>
+        <p:spPr>
+          <a:xfrm>
+            <a:off x="6263640" y="4087368"/>
+            <a:ext cx="3657600" cy="274320"/>
+          </a:xfrm>
+          <a:prstGeom prst="rect">
+            <a:avLst/>
+          </a:prstGeom>
+          <a:noFill/>
+          <a:ln/>
+        </p:spPr>
+        <p:txBody>
+          <a:bodyPr wrap="square" rtlCol="0" anchor="ctr"/>
+          <a:lstStyle/>
+          <a:p>
+            <a:pPr indent="0" marL="0">
+              <a:buNone/>
+            </a:pPr>
+            <a:r>
+              <a:rPr lang="en-US" sz="1000" dirty="0">
+                <a:solidFill>
+                  <a:srgbClr val="1A1A2E"/>
+                </a:solidFill>
+                <a:latin typeface="Calibri" pitchFamily="34" charset="0"/>
+                <a:ea typeface="Calibri" pitchFamily="34" charset="-122"/>
+                <a:cs typeface="Calibri" pitchFamily="34" charset="-120"/>
+              </a:rPr>
+              <a:t>Venue #247 (Bars)</a:t>
+            </a:r>
+            <a:endParaRPr lang="en-US" sz="1000" dirty="0"/>
+          </a:p>
+        </p:txBody>
+      </p:sp>
+      <p:sp>
+        <p:nvSpPr>
+          <p:cNvPr id="25" name="Text 22"/>
+          <p:cNvSpPr/>
+          <p:nvPr/>
+        </p:nvSpPr>
+        <p:spPr>
+          <a:xfrm>
+            <a:off x="9966960" y="4087368"/>
+            <a:ext cx="1691640" cy="274320"/>
+          </a:xfrm>
+          <a:prstGeom prst="rect">
+            <a:avLst/>
+          </a:prstGeom>
+          <a:noFill/>
+          <a:ln/>
+        </p:spPr>
+        <p:txBody>
+          <a:bodyPr wrap="square" rtlCol="0" anchor="ctr"/>
+          <a:lstStyle/>
+          <a:p>
+            <a:pPr algn="r" indent="0" marL="0">
+              <a:buNone/>
+            </a:pPr>
+            <a:r>
+              <a:rPr lang="en-US" sz="1000" b="1" dirty="0">
+                <a:solidFill>
+                  <a:srgbClr val="B8500A"/>
+                </a:solidFill>
+                <a:latin typeface="Calibri" pitchFamily="34" charset="0"/>
+                <a:ea typeface="Calibri" pitchFamily="34" charset="-122"/>
+                <a:cs typeface="Calibri" pitchFamily="34" charset="-120"/>
+              </a:rPr>
+              <a:t>-60%</a:t>
+            </a:r>
+            <a:endParaRPr lang="en-US" sz="1000" dirty="0"/>
+          </a:p>
+        </p:txBody>
+      </p:sp>
+      <p:sp>
+        <p:nvSpPr>
+          <p:cNvPr id="26" name="Text 23"/>
+          <p:cNvSpPr/>
+          <p:nvPr/>
+        </p:nvSpPr>
+        <p:spPr>
+          <a:xfrm>
+            <a:off x="6263640" y="4562856"/>
+            <a:ext cx="5394960" cy="274320"/>
+          </a:xfrm>
+          <a:prstGeom prst="rect">
+            <a:avLst/>
+          </a:prstGeom>
+          <a:noFill/>
+          <a:ln/>
+        </p:spPr>
+        <p:txBody>
+          <a:bodyPr wrap="square" rtlCol="0" anchor="ctr"/>
+          <a:lstStyle/>
+          <a:p>
+            <a:pPr indent="0" marL="0">
+              <a:buNone/>
+            </a:pPr>
+            <a:r>
+              <a:rPr lang="en-US" sz="1200" b="1" dirty="0">
+                <a:solidFill>
+                  <a:srgbClr val="1E2761"/>
+                </a:solidFill>
+                <a:latin typeface="Cambria" pitchFamily="34" charset="0"/>
+                <a:ea typeface="Cambria" pitchFamily="34" charset="-122"/>
+                <a:cs typeface="Cambria" pitchFamily="34" charset="-120"/>
+              </a:rPr>
+              <a:t>Top prospect venues (expansion priority)</a:t>
+            </a:r>
+            <a:endParaRPr lang="en-US" sz="1200" dirty="0"/>
+          </a:p>
+        </p:txBody>
+      </p:sp>
+      <p:sp>
+        <p:nvSpPr>
+          <p:cNvPr id="27" name="Text 24"/>
+          <p:cNvSpPr/>
+          <p:nvPr/>
+        </p:nvSpPr>
+        <p:spPr>
+          <a:xfrm>
+            <a:off x="6263640" y="4892040"/>
+            <a:ext cx="4023360" cy="274320"/>
+          </a:xfrm>
+          <a:prstGeom prst="rect">
+            <a:avLst/>
+          </a:prstGeom>
+          <a:noFill/>
+          <a:ln/>
+        </p:spPr>
+        <p:txBody>
+          <a:bodyPr wrap="square" rtlCol="0" anchor="ctr"/>
+          <a:lstStyle/>
+          <a:p>
+            <a:pPr indent="0" marL="0">
+              <a:buNone/>
+            </a:pPr>
+            <a:r>
+              <a:rPr lang="en-US" sz="1000" dirty="0">
+                <a:solidFill>
+                  <a:srgbClr val="1A1A2E"/>
+                </a:solidFill>
+                <a:latin typeface="Calibri" pitchFamily="34" charset="0"/>
+                <a:ea typeface="Calibri" pitchFamily="34" charset="-122"/>
+                <a:cs typeface="Calibri" pitchFamily="34" charset="-120"/>
+              </a:rPr>
+              <a:t>P0018 — Bars (existing market)</a:t>
+            </a:r>
+            <a:endParaRPr lang="en-US" sz="1000" dirty="0"/>
+          </a:p>
+        </p:txBody>
+      </p:sp>
+      <p:sp>
+        <p:nvSpPr>
+          <p:cNvPr id="28" name="Text 25"/>
+          <p:cNvSpPr/>
+          <p:nvPr/>
+        </p:nvSpPr>
+        <p:spPr>
+          <a:xfrm>
+            <a:off x="10195560" y="4892040"/>
+            <a:ext cx="1463040" cy="274320"/>
+          </a:xfrm>
+          <a:prstGeom prst="rect">
+            <a:avLst/>
+          </a:prstGeom>
+          <a:noFill/>
+          <a:ln/>
+        </p:spPr>
+        <p:txBody>
+          <a:bodyPr wrap="square" rtlCol="0" anchor="ctr"/>
+          <a:lstStyle/>
+          <a:p>
+            <a:pPr algn="r" indent="0" marL="0">
+              <a:buNone/>
+            </a:pPr>
+            <a:r>
+              <a:rPr lang="en-US" sz="1000" b="1" dirty="0">
+                <a:solidFill>
+                  <a:srgbClr val="2C7A57"/>
+                </a:solidFill>
+                <a:latin typeface="Calibri" pitchFamily="34" charset="0"/>
+                <a:ea typeface="Calibri" pitchFamily="34" charset="-122"/>
+                <a:cs typeface="Calibri" pitchFamily="34" charset="-120"/>
+              </a:rPr>
+              <a:t>$684</a:t>
+            </a:r>
+            <a:endParaRPr lang="en-US" sz="1000" dirty="0"/>
+          </a:p>
+        </p:txBody>
+      </p:sp>
+      <p:sp>
+        <p:nvSpPr>
+          <p:cNvPr id="29" name="Text 26"/>
+          <p:cNvSpPr/>
+          <p:nvPr/>
+        </p:nvSpPr>
+        <p:spPr>
+          <a:xfrm>
+            <a:off x="6263640" y="5184648"/>
+            <a:ext cx="4023360" cy="274320"/>
+          </a:xfrm>
+          <a:prstGeom prst="rect">
+            <a:avLst/>
+          </a:prstGeom>
+          <a:noFill/>
+          <a:ln/>
+        </p:spPr>
+        <p:txBody>
+          <a:bodyPr wrap="square" rtlCol="0" anchor="ctr"/>
+          <a:lstStyle/>
+          <a:p>
+            <a:pPr indent="0" marL="0">
+              <a:buNone/>
+            </a:pPr>
+            <a:r>
+              <a:rPr lang="en-US" sz="1000" dirty="0">
+                <a:solidFill>
+                  <a:srgbClr val="1A1A2E"/>
+                </a:solidFill>
+                <a:latin typeface="Calibri" pitchFamily="34" charset="0"/>
+                <a:ea typeface="Calibri" pitchFamily="34" charset="-122"/>
+                <a:cs typeface="Calibri" pitchFamily="34" charset="-120"/>
+              </a:rPr>
+              <a:t>P0055 — Restaurants (existing market)</a:t>
+            </a:r>
+            <a:endParaRPr lang="en-US" sz="1000" dirty="0"/>
+          </a:p>
+        </p:txBody>
+      </p:sp>
+      <p:sp>
+        <p:nvSpPr>
+          <p:cNvPr id="30" name="Text 27"/>
+          <p:cNvSpPr/>
+          <p:nvPr/>
+        </p:nvSpPr>
+        <p:spPr>
+          <a:xfrm>
+            <a:off x="10195560" y="5184648"/>
+            <a:ext cx="1463040" cy="274320"/>
+          </a:xfrm>
+          <a:prstGeom prst="rect">
+            <a:avLst/>
+          </a:prstGeom>
+          <a:noFill/>
+          <a:ln/>
+        </p:spPr>
+        <p:txBody>
+          <a:bodyPr wrap="square" rtlCol="0" anchor="ctr"/>
+          <a:lstStyle/>
+          <a:p>
+            <a:pPr algn="r" indent="0" marL="0">
+              <a:buNone/>
+            </a:pPr>
+            <a:r>
+              <a:rPr lang="en-US" sz="1000" b="1" dirty="0">
+                <a:solidFill>
+                  <a:srgbClr val="2C7A57"/>
+                </a:solidFill>
+                <a:latin typeface="Calibri" pitchFamily="34" charset="0"/>
+                <a:ea typeface="Calibri" pitchFamily="34" charset="-122"/>
+                <a:cs typeface="Calibri" pitchFamily="34" charset="-120"/>
+              </a:rPr>
+              <a:t>$524</a:t>
+            </a:r>
+            <a:endParaRPr lang="en-US" sz="1000" dirty="0"/>
+          </a:p>
+        </p:txBody>
+      </p:sp>
+      <p:sp>
+        <p:nvSpPr>
+          <p:cNvPr id="31" name="Text 28"/>
+          <p:cNvSpPr/>
+          <p:nvPr/>
+        </p:nvSpPr>
+        <p:spPr>
+          <a:xfrm>
+            <a:off x="6263640" y="5477256"/>
+            <a:ext cx="4023360" cy="274320"/>
+          </a:xfrm>
+          <a:prstGeom prst="rect">
+            <a:avLst/>
+          </a:prstGeom>
+          <a:noFill/>
+          <a:ln/>
+        </p:spPr>
+        <p:txBody>
+          <a:bodyPr wrap="square" rtlCol="0" anchor="ctr"/>
+          <a:lstStyle/>
+          <a:p>
+            <a:pPr indent="0" marL="0">
+              <a:buNone/>
+            </a:pPr>
+            <a:r>
+              <a:rPr lang="en-US" sz="1000" dirty="0">
+                <a:solidFill>
+                  <a:srgbClr val="1A1A2E"/>
+                </a:solidFill>
+                <a:latin typeface="Calibri" pitchFamily="34" charset="0"/>
+                <a:ea typeface="Calibri" pitchFamily="34" charset="-122"/>
+                <a:cs typeface="Calibri" pitchFamily="34" charset="-120"/>
+              </a:rPr>
+              <a:t>P0000 — Bars (new market)</a:t>
+            </a:r>
+            <a:endParaRPr lang="en-US" sz="1000" dirty="0"/>
+          </a:p>
+        </p:txBody>
+      </p:sp>
+      <p:sp>
+        <p:nvSpPr>
+          <p:cNvPr id="32" name="Text 29"/>
+          <p:cNvSpPr/>
+          <p:nvPr/>
+        </p:nvSpPr>
+        <p:spPr>
+          <a:xfrm>
+            <a:off x="10195560" y="5477256"/>
+            <a:ext cx="1463040" cy="274320"/>
+          </a:xfrm>
+          <a:prstGeom prst="rect">
+            <a:avLst/>
+          </a:prstGeom>
+          <a:noFill/>
+          <a:ln/>
+        </p:spPr>
+        <p:txBody>
+          <a:bodyPr wrap="square" rtlCol="0" anchor="ctr"/>
+          <a:lstStyle/>
+          <a:p>
+            <a:pPr algn="r" indent="0" marL="0">
+              <a:buNone/>
+            </a:pPr>
+            <a:r>
+              <a:rPr lang="en-US" sz="1000" b="1" dirty="0">
+                <a:solidFill>
+                  <a:srgbClr val="2C7A57"/>
+                </a:solidFill>
+                <a:latin typeface="Calibri" pitchFamily="34" charset="0"/>
+                <a:ea typeface="Calibri" pitchFamily="34" charset="-122"/>
+                <a:cs typeface="Calibri" pitchFamily="34" charset="-120"/>
+              </a:rPr>
+              <a:t>$500</a:t>
+            </a:r>
+            <a:endParaRPr lang="en-US" sz="1000" dirty="0"/>
+          </a:p>
+        </p:txBody>
+      </p:sp>
+      <p:sp>
+        <p:nvSpPr>
+          <p:cNvPr id="33" name="Text 30"/>
+          <p:cNvSpPr/>
+          <p:nvPr/>
+        </p:nvSpPr>
+        <p:spPr>
+          <a:xfrm>
+            <a:off x="6263640" y="5769864"/>
+            <a:ext cx="4023360" cy="274320"/>
+          </a:xfrm>
+          <a:prstGeom prst="rect">
+            <a:avLst/>
+          </a:prstGeom>
+          <a:noFill/>
+          <a:ln/>
+        </p:spPr>
+        <p:txBody>
+          <a:bodyPr wrap="square" rtlCol="0" anchor="ctr"/>
+          <a:lstStyle/>
+          <a:p>
+            <a:pPr indent="0" marL="0">
+              <a:buNone/>
+            </a:pPr>
+            <a:r>
+              <a:rPr lang="en-US" sz="1000" dirty="0">
+                <a:solidFill>
+                  <a:srgbClr val="1A1A2E"/>
+                </a:solidFill>
+                <a:latin typeface="Calibri" pitchFamily="34" charset="0"/>
+                <a:ea typeface="Calibri" pitchFamily="34" charset="-122"/>
+                <a:cs typeface="Calibri" pitchFamily="34" charset="-120"/>
+              </a:rPr>
+              <a:t>P0001 — Bars (new market)</a:t>
+            </a:r>
+            <a:endParaRPr lang="en-US" sz="1000" dirty="0"/>
+          </a:p>
+        </p:txBody>
+      </p:sp>
+      <p:sp>
+        <p:nvSpPr>
+          <p:cNvPr id="34" name="Text 31"/>
+          <p:cNvSpPr/>
+          <p:nvPr/>
+        </p:nvSpPr>
+        <p:spPr>
+          <a:xfrm>
+            <a:off x="10195560" y="5769864"/>
+            <a:ext cx="1463040" cy="274320"/>
+          </a:xfrm>
+          <a:prstGeom prst="rect">
+            <a:avLst/>
+          </a:prstGeom>
+          <a:noFill/>
+          <a:ln/>
+        </p:spPr>
+        <p:txBody>
+          <a:bodyPr wrap="square" rtlCol="0" anchor="ctr"/>
+          <a:lstStyle/>
+          <a:p>
+            <a:pPr algn="r" indent="0" marL="0">
+              <a:buNone/>
+            </a:pPr>
+            <a:r>
+              <a:rPr lang="en-US" sz="1000" b="1" dirty="0">
+                <a:solidFill>
+                  <a:srgbClr val="2C7A57"/>
+                </a:solidFill>
+                <a:latin typeface="Calibri" pitchFamily="34" charset="0"/>
+                <a:ea typeface="Calibri" pitchFamily="34" charset="-122"/>
+                <a:cs typeface="Calibri" pitchFamily="34" charset="-120"/>
+              </a:rPr>
+              <a:t>$496</a:t>
+            </a:r>
+            <a:endParaRPr lang="en-US" sz="1000" dirty="0"/>
+          </a:p>
+        </p:txBody>
+      </p:sp>
+      <p:sp>
+        <p:nvSpPr>
+          <p:cNvPr id="35" name="Text 32"/>
+          <p:cNvSpPr/>
+          <p:nvPr/>
+        </p:nvSpPr>
+        <p:spPr>
+          <a:xfrm>
+            <a:off x="548640" y="6080760"/>
+            <a:ext cx="11064240" cy="411480"/>
+          </a:xfrm>
+          <a:prstGeom prst="rect">
+            <a:avLst/>
+          </a:prstGeom>
+          <a:noFill/>
+          <a:ln/>
+        </p:spPr>
+        <p:txBody>
+          <a:bodyPr wrap="square" rtlCol="0" anchor="ctr"/>
           <a:lstStyle/>
           <a:p>
             <a:pPr indent="0" marL="0">
               <a:lnSpc>
-                <a:spcPts val="1600"/>
+                <a:spcPts val="1200"/>
               </a:lnSpc>
               <a:buNone/>
             </a:pPr>
             <a:r>
-              <a:rPr lang="en-US" sz="1200" dirty="0">
-                <a:solidFill>
-                  <a:srgbClr val="1A1A2E"/>
-                </a:solidFill>
-                <a:latin typeface="Calibri" pitchFamily="34" charset="0"/>
-                <a:ea typeface="Calibri" pitchFamily="34" charset="-122"/>
-                <a:cs typeface="Calibri" pitchFamily="34" charset="-120"/>
-              </a:rPr>
-              <a:t>All figures are synthetic, with a known injected ground-truth effect — used specifically to validate that each method recovers it before trusting it conceptually. Not a claim about any real company's data.</a:t>
-            </a:r>
-            <a:endParaRPr lang="en-US" sz="1200" dirty="0"/>
-          </a:p>
-        </p:txBody>
-      </p:sp>
-      <p:sp>
-        <p:nvSpPr>
-          <p:cNvPr id="6" name="Shape 4"/>
-          <p:cNvSpPr/>
-          <p:nvPr/>
-        </p:nvSpPr>
-        <p:spPr>
-          <a:xfrm>
-            <a:off x="548640" y="2633472"/>
-            <a:ext cx="109728" cy="960120"/>
-          </a:xfrm>
-          <a:prstGeom prst="rect">
-            <a:avLst/>
-          </a:prstGeom>
-          <a:solidFill>
-            <a:srgbClr val="E8871E"/>
-          </a:solidFill>
-          <a:ln/>
-        </p:spPr>
-      </p:sp>
-      <p:sp>
-        <p:nvSpPr>
-          <p:cNvPr id="7" name="Text 5"/>
-          <p:cNvSpPr/>
-          <p:nvPr/>
-        </p:nvSpPr>
-        <p:spPr>
-          <a:xfrm>
-            <a:off x="868680" y="2578608"/>
-            <a:ext cx="2743200" cy="1097280"/>
-          </a:xfrm>
-          <a:prstGeom prst="rect">
-            <a:avLst/>
-          </a:prstGeom>
-          <a:noFill/>
-          <a:ln/>
-        </p:spPr>
-        <p:txBody>
-          <a:bodyPr wrap="square" rtlCol="0" anchor="t"/>
-          <a:lstStyle/>
-          <a:p>
-            <a:pPr indent="0" marL="0">
-              <a:buNone/>
-            </a:pPr>
-            <a:r>
-              <a:rPr lang="en-US" sz="1350" b="1" dirty="0">
-                <a:solidFill>
-                  <a:srgbClr val="1E2761"/>
-                </a:solidFill>
-                <a:latin typeface="Calibri" pitchFamily="34" charset="0"/>
-                <a:ea typeface="Calibri" pitchFamily="34" charset="-122"/>
-                <a:cs typeface="Calibri" pitchFamily="34" charset="-120"/>
-              </a:rPr>
-              <a:t>Media-effectiveness figures</a:t>
-            </a:r>
-            <a:endParaRPr lang="en-US" sz="1350" dirty="0"/>
-          </a:p>
-        </p:txBody>
-      </p:sp>
-      <p:sp>
-        <p:nvSpPr>
-          <p:cNvPr id="8" name="Text 6"/>
-          <p:cNvSpPr/>
-          <p:nvPr/>
-        </p:nvSpPr>
-        <p:spPr>
-          <a:xfrm>
-            <a:off x="3794760" y="2578608"/>
-            <a:ext cx="7863840" cy="1097280"/>
-          </a:xfrm>
-          <a:prstGeom prst="rect">
-            <a:avLst/>
-          </a:prstGeom>
-          <a:noFill/>
-          <a:ln/>
-        </p:spPr>
-        <p:txBody>
-          <a:bodyPr wrap="square" rtlCol="0" anchor="t"/>
-          <a:lstStyle/>
-          <a:p>
-            <a:pPr indent="0" marL="0">
-              <a:lnSpc>
-                <a:spcPts val="1600"/>
-              </a:lnSpc>
-              <a:buNone/>
-            </a:pPr>
-            <a:r>
-              <a:rPr lang="en-US" sz="1200" dirty="0">
-                <a:solidFill>
-                  <a:srgbClr val="1A1A2E"/>
-                </a:solidFill>
-                <a:latin typeface="Calibri" pitchFamily="34" charset="0"/>
-                <a:ea typeface="Calibri" pitchFamily="34" charset="-122"/>
-                <a:cs typeface="Calibri" pitchFamily="34" charset="-120"/>
-              </a:rPr>
-              <a:t>Dwell time, screen count, and similar descriptive parameters shown are illustrative demo values, not researched real industry benchmarks. In production: Nielsen OOH, DSP data (e.g. Vistar), or Atmosphere's own play logs.</a:t>
-            </a:r>
-            <a:endParaRPr lang="en-US" sz="1200" dirty="0"/>
-          </a:p>
-        </p:txBody>
-      </p:sp>
-      <p:sp>
-        <p:nvSpPr>
-          <p:cNvPr id="9" name="Shape 7"/>
-          <p:cNvSpPr/>
-          <p:nvPr/>
-        </p:nvSpPr>
-        <p:spPr>
-          <a:xfrm>
-            <a:off x="548640" y="3840480"/>
-            <a:ext cx="109728" cy="960120"/>
-          </a:xfrm>
-          <a:prstGeom prst="rect">
-            <a:avLst/>
-          </a:prstGeom>
-          <a:solidFill>
-            <a:srgbClr val="E8871E"/>
-          </a:solidFill>
-          <a:ln/>
-        </p:spPr>
-      </p:sp>
-      <p:sp>
-        <p:nvSpPr>
-          <p:cNvPr id="10" name="Text 8"/>
-          <p:cNvSpPr/>
-          <p:nvPr/>
-        </p:nvSpPr>
-        <p:spPr>
-          <a:xfrm>
-            <a:off x="868680" y="3785616"/>
-            <a:ext cx="2743200" cy="1097280"/>
-          </a:xfrm>
-          <a:prstGeom prst="rect">
-            <a:avLst/>
-          </a:prstGeom>
-          <a:noFill/>
-          <a:ln/>
-        </p:spPr>
-        <p:txBody>
-          <a:bodyPr wrap="square" rtlCol="0" anchor="t"/>
-          <a:lstStyle/>
-          <a:p>
-            <a:pPr indent="0" marL="0">
-              <a:buNone/>
-            </a:pPr>
-            <a:r>
-              <a:rPr lang="en-US" sz="1350" b="1" dirty="0">
-                <a:solidFill>
-                  <a:srgbClr val="1E2761"/>
-                </a:solidFill>
-                <a:latin typeface="Calibri" pitchFamily="34" charset="0"/>
-                <a:ea typeface="Calibri" pitchFamily="34" charset="-122"/>
-                <a:cs typeface="Calibri" pitchFamily="34" charset="-120"/>
-              </a:rPr>
-              <a:t>Multi-touch attribution — deliberately not built</a:t>
-            </a:r>
-            <a:endParaRPr lang="en-US" sz="1350" dirty="0"/>
-          </a:p>
-        </p:txBody>
-      </p:sp>
-      <p:sp>
-        <p:nvSpPr>
-          <p:cNvPr id="11" name="Text 9"/>
-          <p:cNvSpPr/>
-          <p:nvPr/>
-        </p:nvSpPr>
-        <p:spPr>
-          <a:xfrm>
-            <a:off x="3794760" y="3785616"/>
-            <a:ext cx="7863840" cy="1097280"/>
-          </a:xfrm>
-          <a:prstGeom prst="rect">
-            <a:avLst/>
-          </a:prstGeom>
-          <a:noFill/>
-          <a:ln/>
-        </p:spPr>
-        <p:txBody>
-          <a:bodyPr wrap="square" rtlCol="0" anchor="t"/>
-          <a:lstStyle/>
-          <a:p>
-            <a:pPr indent="0" marL="0">
-              <a:lnSpc>
-                <a:spcPts val="1600"/>
-              </a:lnSpc>
-              <a:buNone/>
-            </a:pPr>
-            <a:r>
-              <a:rPr lang="en-US" sz="1200" dirty="0">
-                <a:solidFill>
-                  <a:srgbClr val="1A1A2E"/>
-                </a:solidFill>
-                <a:latin typeface="Calibri" pitchFamily="34" charset="0"/>
-                <a:ea typeface="Calibri" pitchFamily="34" charset="-122"/>
-                <a:cs typeface="Calibri" pitchFamily="34" charset="-120"/>
-              </a:rPr>
-              <a:t>Atmosphere's ambient-screen model has no individual-level, cross-venue touchpoint log by default. Building MTA would require purchased mobile location/device-matching data — a real but non-default assumption, so it's scoped out rather than forced.</a:t>
-            </a:r>
-            <a:endParaRPr lang="en-US" sz="1200" dirty="0"/>
-          </a:p>
-        </p:txBody>
-      </p:sp>
-      <p:sp>
-        <p:nvSpPr>
-          <p:cNvPr id="12" name="Shape 10"/>
-          <p:cNvSpPr/>
-          <p:nvPr/>
-        </p:nvSpPr>
-        <p:spPr>
-          <a:xfrm>
-            <a:off x="548640" y="5047488"/>
-            <a:ext cx="109728" cy="960120"/>
-          </a:xfrm>
-          <a:prstGeom prst="rect">
-            <a:avLst/>
-          </a:prstGeom>
-          <a:solidFill>
-            <a:srgbClr val="E8871E"/>
-          </a:solidFill>
-          <a:ln/>
-        </p:spPr>
-      </p:sp>
-      <p:sp>
-        <p:nvSpPr>
-          <p:cNvPr id="13" name="Text 11"/>
-          <p:cNvSpPr/>
-          <p:nvPr/>
-        </p:nvSpPr>
-        <p:spPr>
-          <a:xfrm>
-            <a:off x="868680" y="4992624"/>
-            <a:ext cx="2743200" cy="1097280"/>
-          </a:xfrm>
-          <a:prstGeom prst="rect">
-            <a:avLst/>
-          </a:prstGeom>
-          <a:noFill/>
-          <a:ln/>
-        </p:spPr>
-        <p:txBody>
-          <a:bodyPr wrap="square" rtlCol="0" anchor="t"/>
-          <a:lstStyle/>
-          <a:p>
-            <a:pPr indent="0" marL="0">
-              <a:buNone/>
-            </a:pPr>
-            <a:r>
-              <a:rPr lang="en-US" sz="1350" b="1" dirty="0">
-                <a:solidFill>
-                  <a:srgbClr val="1E2761"/>
-                </a:solidFill>
-                <a:latin typeface="Calibri" pitchFamily="34" charset="0"/>
-                <a:ea typeface="Calibri" pitchFamily="34" charset="-122"/>
-                <a:cs typeface="Calibri" pitchFamily="34" charset="-120"/>
-              </a:rPr>
-              <a:t>Cost assumptions</a:t>
-            </a:r>
-            <a:endParaRPr lang="en-US" sz="1350" dirty="0"/>
-          </a:p>
-        </p:txBody>
-      </p:sp>
-      <p:sp>
-        <p:nvSpPr>
-          <p:cNvPr id="14" name="Text 12"/>
-          <p:cNvSpPr/>
-          <p:nvPr/>
-        </p:nvSpPr>
-        <p:spPr>
-          <a:xfrm>
-            <a:off x="3794760" y="4992624"/>
-            <a:ext cx="7863840" cy="1097280"/>
-          </a:xfrm>
-          <a:prstGeom prst="rect">
-            <a:avLst/>
-          </a:prstGeom>
-          <a:noFill/>
-          <a:ln/>
-        </p:spPr>
-        <p:txBody>
-          <a:bodyPr wrap="square" rtlCol="0" anchor="t"/>
-          <a:lstStyle/>
-          <a:p>
-            <a:pPr indent="0" marL="0">
-              <a:lnSpc>
-                <a:spcPts val="1600"/>
-              </a:lnSpc>
-              <a:buNone/>
-            </a:pPr>
-            <a:r>
-              <a:rPr lang="en-US" sz="1200" dirty="0">
-                <a:solidFill>
-                  <a:srgbClr val="1A1A2E"/>
-                </a:solidFill>
-                <a:latin typeface="Calibri" pitchFamily="34" charset="0"/>
-                <a:ea typeface="Calibri" pitchFamily="34" charset="-122"/>
-                <a:cs typeface="Calibri" pitchFamily="34" charset="-120"/>
-              </a:rPr>
-              <a:t>The $/frequency-unit figures behind the budget allocator are illustrative, editable placeholders — in production these come from Atmosphere's own rate card by venue type and daypart.</a:t>
-            </a:r>
-            <a:endParaRPr lang="en-US" sz="1200" dirty="0"/>
-          </a:p>
-        </p:txBody>
-      </p:sp>
-      <p:sp>
-        <p:nvSpPr>
-          <p:cNvPr id="15" name="Text 13"/>
+              <a:rPr lang="en-US" sz="1000" i="1" dirty="0">
+                <a:solidFill>
+                  <a:srgbClr val="5B6178"/>
+                </a:solidFill>
+                <a:latin typeface="Calibri" pitchFamily="34" charset="0"/>
+                <a:ea typeface="Calibri" pitchFamily="34" charset="-122"/>
+                <a:cs typeface="Calibri" pitchFamily="34" charset="-120"/>
+              </a:rPr>
+              <a:t>Flags come from 5-fold out-of-fold predictions, never a model scoring the venue it was trained on. Phase 1's calibrated-lift feature carries near-zero importance — honest, since it's constant within venue_type once venue_type itself is a feature.</a:t>
+            </a:r>
+            <a:endParaRPr lang="en-US" sz="1000" dirty="0"/>
+          </a:p>
+        </p:txBody>
+      </p:sp>
+      <p:sp>
+        <p:nvSpPr>
+          <p:cNvPr id="36" name="Text 33"/>
           <p:cNvSpPr/>
           <p:nvPr/>
         </p:nvSpPr>
@@ -3961,7 +5120,7 @@
                 <a:ea typeface="Calibri" pitchFamily="34" charset="-122"/>
                 <a:cs typeface="Calibri" pitchFamily="34" charset="-120"/>
               </a:rPr>
-              <a:t>Honest scope</a:t>
+              <a:t>Venue economics — Phase 2</a:t>
             </a:r>
             <a:endParaRPr lang="en-US" sz="900" dirty="0"/>
           </a:p>
@@ -3969,7 +5128,7 @@
       </p:sp>
       <p:sp>
         <p:nvSpPr>
-          <p:cNvPr id="16" name="Text 14"/>
+          <p:cNvPr id="37" name="Text 34"/>
           <p:cNvSpPr/>
           <p:nvPr/>
         </p:nvSpPr>
@@ -4017,6 +5176,559 @@
 <file path=ppt/slides/slide11.xml><?xml version="1.0" encoding="utf-8"?>
 <p:sld xmlns:a="http://schemas.openxmlformats.org/drawingml/2006/main" xmlns:r="http://schemas.openxmlformats.org/officeDocument/2006/relationships" xmlns:p="http://schemas.openxmlformats.org/presentationml/2006/main">
   <p:cSld name="Slide 11">
+    <p:bg>
+      <p:bgPr>
+        <a:solidFill>
+          <a:srgbClr val="FFFFFF"/>
+        </a:solidFill>
+      </p:bgPr>
+    </p:bg>
+    <p:spTree>
+      <p:nvGrpSpPr>
+        <p:cNvPr id="1" name=""/>
+        <p:cNvGrpSpPr/>
+        <p:nvPr/>
+      </p:nvGrpSpPr>
+      <p:grpSpPr>
+        <a:xfrm>
+          <a:off x="0" y="0"/>
+          <a:ext cx="0" cy="0"/>
+          <a:chOff x="0" y="0"/>
+          <a:chExt cx="0" cy="0"/>
+        </a:xfrm>
+      </p:grpSpPr>
+      <p:sp>
+        <p:nvSpPr>
+          <p:cNvPr id="2" name="Text 0"/>
+          <p:cNvSpPr/>
+          <p:nvPr/>
+        </p:nvSpPr>
+        <p:spPr>
+          <a:xfrm>
+            <a:off x="548640" y="457200"/>
+            <a:ext cx="7315200" cy="640080"/>
+          </a:xfrm>
+          <a:prstGeom prst="rect">
+            <a:avLst/>
+          </a:prstGeom>
+          <a:noFill/>
+          <a:ln/>
+        </p:spPr>
+        <p:txBody>
+          <a:bodyPr wrap="square" rtlCol="0" anchor="ctr"/>
+          <a:lstStyle/>
+          <a:p>
+            <a:pPr indent="0" marL="0">
+              <a:buNone/>
+            </a:pPr>
+            <a:r>
+              <a:rPr lang="en-US" sz="3000" b="1" dirty="0">
+                <a:solidFill>
+                  <a:srgbClr val="1E2761"/>
+                </a:solidFill>
+                <a:latin typeface="Cambria" pitchFamily="34" charset="0"/>
+                <a:ea typeface="Cambria" pitchFamily="34" charset="-122"/>
+                <a:cs typeface="Cambria" pitchFamily="34" charset="-120"/>
+              </a:rPr>
+              <a:t>Honest scope</a:t>
+            </a:r>
+            <a:endParaRPr lang="en-US" sz="3000" dirty="0"/>
+          </a:p>
+        </p:txBody>
+      </p:sp>
+      <p:sp>
+        <p:nvSpPr>
+          <p:cNvPr id="3" name="Shape 1"/>
+          <p:cNvSpPr/>
+          <p:nvPr/>
+        </p:nvSpPr>
+        <p:spPr>
+          <a:xfrm>
+            <a:off x="548640" y="1426464"/>
+            <a:ext cx="109728" cy="960120"/>
+          </a:xfrm>
+          <a:prstGeom prst="rect">
+            <a:avLst/>
+          </a:prstGeom>
+          <a:solidFill>
+            <a:srgbClr val="E8871E"/>
+          </a:solidFill>
+          <a:ln/>
+        </p:spPr>
+      </p:sp>
+      <p:sp>
+        <p:nvSpPr>
+          <p:cNvPr id="4" name="Text 2"/>
+          <p:cNvSpPr/>
+          <p:nvPr/>
+        </p:nvSpPr>
+        <p:spPr>
+          <a:xfrm>
+            <a:off x="868680" y="1371600"/>
+            <a:ext cx="2743200" cy="1097280"/>
+          </a:xfrm>
+          <a:prstGeom prst="rect">
+            <a:avLst/>
+          </a:prstGeom>
+          <a:noFill/>
+          <a:ln/>
+        </p:spPr>
+        <p:txBody>
+          <a:bodyPr wrap="square" rtlCol="0" anchor="t"/>
+          <a:lstStyle/>
+          <a:p>
+            <a:pPr indent="0" marL="0">
+              <a:buNone/>
+            </a:pPr>
+            <a:r>
+              <a:rPr lang="en-US" sz="1350" b="1" dirty="0">
+                <a:solidFill>
+                  <a:srgbClr val="1E2761"/>
+                </a:solidFill>
+                <a:latin typeface="Calibri" pitchFamily="34" charset="0"/>
+                <a:ea typeface="Calibri" pitchFamily="34" charset="-122"/>
+                <a:cs typeface="Calibri" pitchFamily="34" charset="-120"/>
+              </a:rPr>
+              <a:t>Synthetic data</a:t>
+            </a:r>
+            <a:endParaRPr lang="en-US" sz="1350" dirty="0"/>
+          </a:p>
+        </p:txBody>
+      </p:sp>
+      <p:sp>
+        <p:nvSpPr>
+          <p:cNvPr id="5" name="Text 3"/>
+          <p:cNvSpPr/>
+          <p:nvPr/>
+        </p:nvSpPr>
+        <p:spPr>
+          <a:xfrm>
+            <a:off x="3794760" y="1371600"/>
+            <a:ext cx="7863840" cy="1097280"/>
+          </a:xfrm>
+          <a:prstGeom prst="rect">
+            <a:avLst/>
+          </a:prstGeom>
+          <a:noFill/>
+          <a:ln/>
+        </p:spPr>
+        <p:txBody>
+          <a:bodyPr wrap="square" rtlCol="0" anchor="t"/>
+          <a:lstStyle/>
+          <a:p>
+            <a:pPr indent="0" marL="0">
+              <a:lnSpc>
+                <a:spcPts val="1600"/>
+              </a:lnSpc>
+              <a:buNone/>
+            </a:pPr>
+            <a:r>
+              <a:rPr lang="en-US" sz="1200" dirty="0">
+                <a:solidFill>
+                  <a:srgbClr val="1A1A2E"/>
+                </a:solidFill>
+                <a:latin typeface="Calibri" pitchFamily="34" charset="0"/>
+                <a:ea typeface="Calibri" pitchFamily="34" charset="-122"/>
+                <a:cs typeface="Calibri" pitchFamily="34" charset="-120"/>
+              </a:rPr>
+              <a:t>All figures — Phase 1 and Phase 2 — are synthetic, with a known injected ground-truth effect used specifically to validate that each method recovers it before trusting it conceptually. Not a claim about any real company's data.</a:t>
+            </a:r>
+            <a:endParaRPr lang="en-US" sz="1200" dirty="0"/>
+          </a:p>
+        </p:txBody>
+      </p:sp>
+      <p:sp>
+        <p:nvSpPr>
+          <p:cNvPr id="6" name="Shape 4"/>
+          <p:cNvSpPr/>
+          <p:nvPr/>
+        </p:nvSpPr>
+        <p:spPr>
+          <a:xfrm>
+            <a:off x="548640" y="2633472"/>
+            <a:ext cx="109728" cy="960120"/>
+          </a:xfrm>
+          <a:prstGeom prst="rect">
+            <a:avLst/>
+          </a:prstGeom>
+          <a:solidFill>
+            <a:srgbClr val="E8871E"/>
+          </a:solidFill>
+          <a:ln/>
+        </p:spPr>
+      </p:sp>
+      <p:sp>
+        <p:nvSpPr>
+          <p:cNvPr id="7" name="Text 5"/>
+          <p:cNvSpPr/>
+          <p:nvPr/>
+        </p:nvSpPr>
+        <p:spPr>
+          <a:xfrm>
+            <a:off x="868680" y="2578608"/>
+            <a:ext cx="2743200" cy="1097280"/>
+          </a:xfrm>
+          <a:prstGeom prst="rect">
+            <a:avLst/>
+          </a:prstGeom>
+          <a:noFill/>
+          <a:ln/>
+        </p:spPr>
+        <p:txBody>
+          <a:bodyPr wrap="square" rtlCol="0" anchor="t"/>
+          <a:lstStyle/>
+          <a:p>
+            <a:pPr indent="0" marL="0">
+              <a:buNone/>
+            </a:pPr>
+            <a:r>
+              <a:rPr lang="en-US" sz="1350" b="1" dirty="0">
+                <a:solidFill>
+                  <a:srgbClr val="1E2761"/>
+                </a:solidFill>
+                <a:latin typeface="Calibri" pitchFamily="34" charset="0"/>
+                <a:ea typeface="Calibri" pitchFamily="34" charset="-122"/>
+                <a:cs typeface="Calibri" pitchFamily="34" charset="-120"/>
+              </a:rPr>
+              <a:t>Media-effectiveness &amp; rate-card figures</a:t>
+            </a:r>
+            <a:endParaRPr lang="en-US" sz="1350" dirty="0"/>
+          </a:p>
+        </p:txBody>
+      </p:sp>
+      <p:sp>
+        <p:nvSpPr>
+          <p:cNvPr id="8" name="Text 6"/>
+          <p:cNvSpPr/>
+          <p:nvPr/>
+        </p:nvSpPr>
+        <p:spPr>
+          <a:xfrm>
+            <a:off x="3794760" y="2578608"/>
+            <a:ext cx="7863840" cy="1097280"/>
+          </a:xfrm>
+          <a:prstGeom prst="rect">
+            <a:avLst/>
+          </a:prstGeom>
+          <a:noFill/>
+          <a:ln/>
+        </p:spPr>
+        <p:txBody>
+          <a:bodyPr wrap="square" rtlCol="0" anchor="t"/>
+          <a:lstStyle/>
+          <a:p>
+            <a:pPr indent="0" marL="0">
+              <a:lnSpc>
+                <a:spcPts val="1600"/>
+              </a:lnSpc>
+              <a:buNone/>
+            </a:pPr>
+            <a:r>
+              <a:rPr lang="en-US" sz="1200" dirty="0">
+                <a:solidFill>
+                  <a:srgbClr val="1A1A2E"/>
+                </a:solidFill>
+                <a:latin typeface="Calibri" pitchFamily="34" charset="0"/>
+                <a:ea typeface="Calibri" pitchFamily="34" charset="-122"/>
+                <a:cs typeface="Calibri" pitchFamily="34" charset="-120"/>
+              </a:rPr>
+              <a:t>Dwell time, screen count, ad rate card, and similar parameters shown are illustrative demo values, not researched real industry benchmarks. In production: Nielsen OOH, DSP data (e.g. Vistar), or Atmosphere's own play logs and rate card.</a:t>
+            </a:r>
+            <a:endParaRPr lang="en-US" sz="1200" dirty="0"/>
+          </a:p>
+        </p:txBody>
+      </p:sp>
+      <p:sp>
+        <p:nvSpPr>
+          <p:cNvPr id="9" name="Shape 7"/>
+          <p:cNvSpPr/>
+          <p:nvPr/>
+        </p:nvSpPr>
+        <p:spPr>
+          <a:xfrm>
+            <a:off x="548640" y="3840480"/>
+            <a:ext cx="109728" cy="960120"/>
+          </a:xfrm>
+          <a:prstGeom prst="rect">
+            <a:avLst/>
+          </a:prstGeom>
+          <a:solidFill>
+            <a:srgbClr val="E8871E"/>
+          </a:solidFill>
+          <a:ln/>
+        </p:spPr>
+      </p:sp>
+      <p:sp>
+        <p:nvSpPr>
+          <p:cNvPr id="10" name="Text 8"/>
+          <p:cNvSpPr/>
+          <p:nvPr/>
+        </p:nvSpPr>
+        <p:spPr>
+          <a:xfrm>
+            <a:off x="868680" y="3785616"/>
+            <a:ext cx="2743200" cy="1097280"/>
+          </a:xfrm>
+          <a:prstGeom prst="rect">
+            <a:avLst/>
+          </a:prstGeom>
+          <a:noFill/>
+          <a:ln/>
+        </p:spPr>
+        <p:txBody>
+          <a:bodyPr wrap="square" rtlCol="0" anchor="t"/>
+          <a:lstStyle/>
+          <a:p>
+            <a:pPr indent="0" marL="0">
+              <a:buNone/>
+            </a:pPr>
+            <a:r>
+              <a:rPr lang="en-US" sz="1350" b="1" dirty="0">
+                <a:solidFill>
+                  <a:srgbClr val="1E2761"/>
+                </a:solidFill>
+                <a:latin typeface="Calibri" pitchFamily="34" charset="0"/>
+                <a:ea typeface="Calibri" pitchFamily="34" charset="-122"/>
+                <a:cs typeface="Calibri" pitchFamily="34" charset="-120"/>
+              </a:rPr>
+              <a:t>Multi-touch attribution — deliberately not built</a:t>
+            </a:r>
+            <a:endParaRPr lang="en-US" sz="1350" dirty="0"/>
+          </a:p>
+        </p:txBody>
+      </p:sp>
+      <p:sp>
+        <p:nvSpPr>
+          <p:cNvPr id="11" name="Text 9"/>
+          <p:cNvSpPr/>
+          <p:nvPr/>
+        </p:nvSpPr>
+        <p:spPr>
+          <a:xfrm>
+            <a:off x="3794760" y="3785616"/>
+            <a:ext cx="7863840" cy="1097280"/>
+          </a:xfrm>
+          <a:prstGeom prst="rect">
+            <a:avLst/>
+          </a:prstGeom>
+          <a:noFill/>
+          <a:ln/>
+        </p:spPr>
+        <p:txBody>
+          <a:bodyPr wrap="square" rtlCol="0" anchor="t"/>
+          <a:lstStyle/>
+          <a:p>
+            <a:pPr indent="0" marL="0">
+              <a:lnSpc>
+                <a:spcPts val="1600"/>
+              </a:lnSpc>
+              <a:buNone/>
+            </a:pPr>
+            <a:r>
+              <a:rPr lang="en-US" sz="1200" dirty="0">
+                <a:solidFill>
+                  <a:srgbClr val="1A1A2E"/>
+                </a:solidFill>
+                <a:latin typeface="Calibri" pitchFamily="34" charset="0"/>
+                <a:ea typeface="Calibri" pitchFamily="34" charset="-122"/>
+                <a:cs typeface="Calibri" pitchFamily="34" charset="-120"/>
+              </a:rPr>
+              <a:t>Atmosphere's ambient-screen model has no individual-level, cross-venue touchpoint log by default. Building MTA would require purchased mobile location/device-matching data — a real but non-default assumption, so it's scoped out rather than forced.</a:t>
+            </a:r>
+            <a:endParaRPr lang="en-US" sz="1200" dirty="0"/>
+          </a:p>
+        </p:txBody>
+      </p:sp>
+      <p:sp>
+        <p:nvSpPr>
+          <p:cNvPr id="12" name="Shape 10"/>
+          <p:cNvSpPr/>
+          <p:nvPr/>
+        </p:nvSpPr>
+        <p:spPr>
+          <a:xfrm>
+            <a:off x="548640" y="5047488"/>
+            <a:ext cx="109728" cy="960120"/>
+          </a:xfrm>
+          <a:prstGeom prst="rect">
+            <a:avLst/>
+          </a:prstGeom>
+          <a:solidFill>
+            <a:srgbClr val="E8871E"/>
+          </a:solidFill>
+          <a:ln/>
+        </p:spPr>
+      </p:sp>
+      <p:sp>
+        <p:nvSpPr>
+          <p:cNvPr id="13" name="Text 11"/>
+          <p:cNvSpPr/>
+          <p:nvPr/>
+        </p:nvSpPr>
+        <p:spPr>
+          <a:xfrm>
+            <a:off x="868680" y="4992624"/>
+            <a:ext cx="2743200" cy="1097280"/>
+          </a:xfrm>
+          <a:prstGeom prst="rect">
+            <a:avLst/>
+          </a:prstGeom>
+          <a:noFill/>
+          <a:ln/>
+        </p:spPr>
+        <p:txBody>
+          <a:bodyPr wrap="square" rtlCol="0" anchor="t"/>
+          <a:lstStyle/>
+          <a:p>
+            <a:pPr indent="0" marL="0">
+              <a:buNone/>
+            </a:pPr>
+            <a:r>
+              <a:rPr lang="en-US" sz="1350" b="1" dirty="0">
+                <a:solidFill>
+                  <a:srgbClr val="1E2761"/>
+                </a:solidFill>
+                <a:latin typeface="Calibri" pitchFamily="34" charset="0"/>
+                <a:ea typeface="Calibri" pitchFamily="34" charset="-122"/>
+                <a:cs typeface="Calibri" pitchFamily="34" charset="-120"/>
+              </a:rPr>
+              <a:t>Cost &amp; revenue assumptions</a:t>
+            </a:r>
+            <a:endParaRPr lang="en-US" sz="1350" dirty="0"/>
+          </a:p>
+        </p:txBody>
+      </p:sp>
+      <p:sp>
+        <p:nvSpPr>
+          <p:cNvPr id="14" name="Text 12"/>
+          <p:cNvSpPr/>
+          <p:nvPr/>
+        </p:nvSpPr>
+        <p:spPr>
+          <a:xfrm>
+            <a:off x="3794760" y="4992624"/>
+            <a:ext cx="7863840" cy="1097280"/>
+          </a:xfrm>
+          <a:prstGeom prst="rect">
+            <a:avLst/>
+          </a:prstGeom>
+          <a:noFill/>
+          <a:ln/>
+        </p:spPr>
+        <p:txBody>
+          <a:bodyPr wrap="square" rtlCol="0" anchor="t"/>
+          <a:lstStyle/>
+          <a:p>
+            <a:pPr indent="0" marL="0">
+              <a:lnSpc>
+                <a:spcPts val="1600"/>
+              </a:lnSpc>
+              <a:buNone/>
+            </a:pPr>
+            <a:r>
+              <a:rPr lang="en-US" sz="1200" dirty="0">
+                <a:solidFill>
+                  <a:srgbClr val="1A1A2E"/>
+                </a:solidFill>
+                <a:latin typeface="Calibri" pitchFamily="34" charset="0"/>
+                <a:ea typeface="Calibri" pitchFamily="34" charset="-122"/>
+                <a:cs typeface="Calibri" pitchFamily="34" charset="-120"/>
+              </a:rPr>
+              <a:t>The $/frequency-unit figures behind the budget allocator, and the ad-rate-card behind Phase 2's revenue model, are illustrative, editable placeholders — in production these come from Atmosphere's own rate card by venue type and daypart.</a:t>
+            </a:r>
+            <a:endParaRPr lang="en-US" sz="1200" dirty="0"/>
+          </a:p>
+        </p:txBody>
+      </p:sp>
+      <p:sp>
+        <p:nvSpPr>
+          <p:cNvPr id="15" name="Text 13"/>
+          <p:cNvSpPr/>
+          <p:nvPr/>
+        </p:nvSpPr>
+        <p:spPr>
+          <a:xfrm>
+            <a:off x="457200" y="6537960"/>
+            <a:ext cx="7315200" cy="274320"/>
+          </a:xfrm>
+          <a:prstGeom prst="rect">
+            <a:avLst/>
+          </a:prstGeom>
+          <a:noFill/>
+          <a:ln/>
+        </p:spPr>
+        <p:txBody>
+          <a:bodyPr wrap="square" rtlCol="0" anchor="ctr"/>
+          <a:lstStyle/>
+          <a:p>
+            <a:pPr indent="0" marL="0">
+              <a:buNone/>
+            </a:pPr>
+            <a:r>
+              <a:rPr lang="en-US" sz="900" dirty="0">
+                <a:solidFill>
+                  <a:srgbClr val="5B6178"/>
+                </a:solidFill>
+                <a:latin typeface="Calibri" pitchFamily="34" charset="0"/>
+                <a:ea typeface="Calibri" pitchFamily="34" charset="-122"/>
+                <a:cs typeface="Calibri" pitchFamily="34" charset="-120"/>
+              </a:rPr>
+              <a:t>Honest scope</a:t>
+            </a:r>
+            <a:endParaRPr lang="en-US" sz="900" dirty="0"/>
+          </a:p>
+        </p:txBody>
+      </p:sp>
+      <p:sp>
+        <p:nvSpPr>
+          <p:cNvPr id="16" name="Text 14"/>
+          <p:cNvSpPr/>
+          <p:nvPr/>
+        </p:nvSpPr>
+        <p:spPr>
+          <a:xfrm>
+            <a:off x="7589520" y="6537960"/>
+            <a:ext cx="4114800" cy="274320"/>
+          </a:xfrm>
+          <a:prstGeom prst="rect">
+            <a:avLst/>
+          </a:prstGeom>
+          <a:noFill/>
+          <a:ln/>
+        </p:spPr>
+        <p:txBody>
+          <a:bodyPr wrap="square" rtlCol="0" anchor="ctr"/>
+          <a:lstStyle/>
+          <a:p>
+            <a:pPr algn="r" indent="0" marL="0">
+              <a:buNone/>
+            </a:pPr>
+            <a:r>
+              <a:rPr lang="en-US" sz="900" dirty="0">
+                <a:solidFill>
+                  <a:srgbClr val="5B6178"/>
+                </a:solidFill>
+                <a:latin typeface="Calibri" pitchFamily="34" charset="0"/>
+                <a:ea typeface="Calibri" pitchFamily="34" charset="-122"/>
+                <a:cs typeface="Calibri" pitchFamily="34" charset="-120"/>
+              </a:rPr>
+              <a:t>Synthetic demo — validated against a known injected ground truth</a:t>
+            </a:r>
+            <a:endParaRPr lang="en-US" sz="900" dirty="0"/>
+          </a:p>
+        </p:txBody>
+      </p:sp>
+    </p:spTree>
+  </p:cSld>
+  <p:clrMapOvr>
+    <a:masterClrMapping/>
+  </p:clrMapOvr>
+</p:sld>
+</file>
+
+<file path=ppt/slides/slide12.xml><?xml version="1.0" encoding="utf-8"?>
+<p:sld xmlns:a="http://schemas.openxmlformats.org/drawingml/2006/main" xmlns:r="http://schemas.openxmlformats.org/officeDocument/2006/relationships" xmlns:p="http://schemas.openxmlformats.org/presentationml/2006/main">
+  <p:cSld name="Slide 12">
     <p:bg>
       <p:bgPr>
         <a:solidFill>
@@ -4475,7 +6187,7 @@
                 <a:ea typeface="Calibri" pitchFamily="34" charset="-122"/>
                 <a:cs typeface="Calibri" pitchFamily="34" charset="-120"/>
               </a:rPr>
-              <a:t>Scope honestly: MTA excluded and why, illustrative parameters flagged, Phase 2 (venue economics) designed and ready to build.</a:t>
+              <a:t>One connected system, not two projects: Phase 2's venue-revenue model reuses Phase 1's causal-value input, recovers latent ground truth at 0.95 correlation, and cleanly separates market-level effects from venue-level execution gaps.</a:t>
             </a:r>
             <a:endParaRPr lang="en-US" sz="1450" dirty="0"/>
           </a:p>
@@ -4560,24 +6272,24 @@
         </p:nvSpPr>
         <p:spPr>
           <a:xfrm>
-            <a:off x="548640" y="457200"/>
-            <a:ext cx="10972800" cy="640080"/>
-          </a:xfrm>
-          <a:prstGeom prst="rect">
-            <a:avLst/>
-          </a:prstGeom>
-          <a:noFill/>
-          <a:ln/>
-        </p:spPr>
-        <p:txBody>
-          <a:bodyPr wrap="square" rtlCol="0" anchor="ctr"/>
-          <a:lstStyle/>
-          <a:p>
-            <a:pPr indent="0" marL="0">
-              <a:buNone/>
-            </a:pPr>
-            <a:r>
-              <a:rPr lang="en-US" sz="3000" b="1" dirty="0">
+            <a:off x="548640" y="411480"/>
+            <a:ext cx="10972800" cy="594360"/>
+          </a:xfrm>
+          <a:prstGeom prst="rect">
+            <a:avLst/>
+          </a:prstGeom>
+          <a:noFill/>
+          <a:ln/>
+        </p:spPr>
+        <p:txBody>
+          <a:bodyPr wrap="square" rtlCol="0" anchor="ctr"/>
+          <a:lstStyle/>
+          <a:p>
+            <a:pPr indent="0" marL="0">
+              <a:buNone/>
+            </a:pPr>
+            <a:r>
+              <a:rPr lang="en-US" sz="2800" b="1" dirty="0">
                 <a:solidFill>
                   <a:srgbClr val="1E2761"/>
                 </a:solidFill>
@@ -4585,9 +6297,9 @@
                 <a:ea typeface="Cambria" pitchFamily="34" charset="-122"/>
                 <a:cs typeface="Cambria" pitchFamily="34" charset="-120"/>
               </a:rPr>
-              <a:t>Two questions this project answers</a:t>
-            </a:r>
-            <a:endParaRPr lang="en-US" sz="3000" dirty="0"/>
+              <a:t>Three questions this project answers</a:t>
+            </a:r>
+            <a:endParaRPr lang="en-US" sz="2800" dirty="0"/>
           </a:p>
         </p:txBody>
       </p:sp>
@@ -4599,12 +6311,12 @@
         </p:nvSpPr>
         <p:spPr>
           <a:xfrm>
-            <a:off x="548640" y="1554480"/>
-            <a:ext cx="5212080" cy="4480560"/>
+            <a:off x="548640" y="1371600"/>
+            <a:ext cx="3520440" cy="4709160"/>
           </a:xfrm>
           <a:prstGeom prst="roundRect">
             <a:avLst>
-              <a:gd name="adj" fmla="val 2449"/>
+              <a:gd name="adj" fmla="val 3117"/>
             </a:avLst>
           </a:prstGeom>
           <a:solidFill>
@@ -4628,8 +6340,8 @@
         </p:nvSpPr>
         <p:spPr>
           <a:xfrm>
-            <a:off x="914400" y="1920240"/>
-            <a:ext cx="594360" cy="594360"/>
+            <a:off x="868680" y="1691640"/>
+            <a:ext cx="548640" cy="548640"/>
           </a:xfrm>
           <a:prstGeom prst="ellipse">
             <a:avLst/>
@@ -4648,8 +6360,8 @@
         </p:nvSpPr>
         <p:spPr>
           <a:xfrm>
-            <a:off x="914400" y="1920240"/>
-            <a:ext cx="594360" cy="594360"/>
+            <a:off x="868680" y="1691640"/>
+            <a:ext cx="548640" cy="548640"/>
           </a:xfrm>
           <a:prstGeom prst="rect">
             <a:avLst/>
@@ -4665,7 +6377,7 @@
               <a:buNone/>
             </a:pPr>
             <a:r>
-              <a:rPr lang="en-US" sz="2200" b="1" dirty="0">
+              <a:rPr lang="en-US" sz="2000" b="1" dirty="0">
                 <a:solidFill>
                   <a:srgbClr val="FFFFFF"/>
                 </a:solidFill>
@@ -4675,7 +6387,7 @@
               </a:rPr>
               <a:t>1</a:t>
             </a:r>
-            <a:endParaRPr lang="en-US" sz="2200" dirty="0"/>
+            <a:endParaRPr lang="en-US" sz="2000" dirty="0"/>
           </a:p>
         </p:txBody>
       </p:sp>
@@ -4687,24 +6399,27 @@
         </p:nvSpPr>
         <p:spPr>
           <a:xfrm>
-            <a:off x="914400" y="2697480"/>
-            <a:ext cx="4480560" cy="822960"/>
-          </a:xfrm>
-          <a:prstGeom prst="rect">
-            <a:avLst/>
-          </a:prstGeom>
-          <a:noFill/>
-          <a:ln/>
-        </p:spPr>
-        <p:txBody>
-          <a:bodyPr wrap="square" rtlCol="0" anchor="ctr"/>
-          <a:lstStyle/>
-          <a:p>
-            <a:pPr indent="0" marL="0">
-              <a:buNone/>
-            </a:pPr>
-            <a:r>
-              <a:rPr lang="en-US" sz="1900" b="1" dirty="0">
+            <a:off x="868680" y="2377440"/>
+            <a:ext cx="2880360" cy="1051560"/>
+          </a:xfrm>
+          <a:prstGeom prst="rect">
+            <a:avLst/>
+          </a:prstGeom>
+          <a:noFill/>
+          <a:ln/>
+        </p:spPr>
+        <p:txBody>
+          <a:bodyPr wrap="square" rtlCol="0" anchor="ctr"/>
+          <a:lstStyle/>
+          <a:p>
+            <a:pPr indent="0" marL="0">
+              <a:lnSpc>
+                <a:spcPts val="1900"/>
+              </a:lnSpc>
+              <a:buNone/>
+            </a:pPr>
+            <a:r>
+              <a:rPr lang="en-US" sz="1600" b="1" dirty="0">
                 <a:solidFill>
                   <a:srgbClr val="1E2761"/>
                 </a:solidFill>
@@ -4714,7 +6429,7 @@
               </a:rPr>
               <a:t>Did the campaign actually work?</a:t>
             </a:r>
-            <a:endParaRPr lang="en-US" sz="1900" dirty="0"/>
+            <a:endParaRPr lang="en-US" sz="1600" dirty="0"/>
           </a:p>
         </p:txBody>
       </p:sp>
@@ -4726,8 +6441,8 @@
         </p:nvSpPr>
         <p:spPr>
           <a:xfrm>
-            <a:off x="914400" y="3474720"/>
-            <a:ext cx="4480560" cy="2286000"/>
+            <a:off x="868680" y="3520440"/>
+            <a:ext cx="2880360" cy="2331720"/>
           </a:xfrm>
           <a:prstGeom prst="rect">
             <a:avLst/>
@@ -4741,12 +6456,12 @@
           <a:p>
             <a:pPr indent="0" marL="0">
               <a:lnSpc>
-                <a:spcPts val="1900"/>
+                <a:spcPts val="1600"/>
               </a:lnSpc>
               <a:buNone/>
             </a:pPr>
             <a:r>
-              <a:rPr lang="en-US" sz="1300" dirty="0">
+              <a:rPr lang="en-US" sz="1150" dirty="0">
                 <a:solidFill>
                   <a:srgbClr val="1A1A2E"/>
                 </a:solidFill>
@@ -4756,26 +6471,26 @@
               </a:rPr>
               <a:t>Isolate the TRUE incremental foot traffic caused by ad exposure — net of seasonality, trend, and each venue's own baseline pattern.</a:t>
             </a:r>
-            <a:endParaRPr lang="en-US" sz="1300" dirty="0"/>
+            <a:endParaRPr lang="en-US" sz="1150" dirty="0"/>
           </a:p>
           <a:p>
             <a:pPr indent="0" marL="0">
               <a:lnSpc>
-                <a:spcPts val="1900"/>
+                <a:spcPts val="1600"/>
               </a:lnSpc>
               <a:buNone/>
             </a:pPr>
-            <a:endParaRPr lang="en-US" sz="1300" dirty="0"/>
+            <a:endParaRPr lang="en-US" sz="1150" dirty="0"/>
           </a:p>
           <a:p>
             <a:pPr indent="0" marL="0">
               <a:lnSpc>
-                <a:spcPts val="1900"/>
+                <a:spcPts val="1600"/>
               </a:lnSpc>
               <a:buNone/>
             </a:pPr>
             <a:r>
-              <a:rPr lang="en-US" sz="1300" dirty="0">
+              <a:rPr lang="en-US" sz="1150" dirty="0">
                 <a:solidFill>
                   <a:srgbClr val="1A1A2E"/>
                 </a:solidFill>
@@ -4783,9 +6498,9 @@
                 <a:ea typeface="Calibri" pitchFamily="34" charset="-122"/>
                 <a:cs typeface="Calibri" pitchFamily="34" charset="-120"/>
               </a:rPr>
-              <a:t>This is the sell-side differentiator: measurement Atmosphere's go-to-market team can take to market and clients can trust.</a:t>
-            </a:r>
-            <a:endParaRPr lang="en-US" sz="1300" dirty="0"/>
+              <a:t>The sell-side differentiator: measurement Atmosphere's go-to-market team can take to market and clients can trust.</a:t>
+            </a:r>
+            <a:endParaRPr lang="en-US" sz="1150" dirty="0"/>
           </a:p>
         </p:txBody>
       </p:sp>
@@ -4797,12 +6512,12 @@
         </p:nvSpPr>
         <p:spPr>
           <a:xfrm>
-            <a:off x="6126480" y="1554480"/>
-            <a:ext cx="5212080" cy="4480560"/>
+            <a:off x="4343400" y="1371600"/>
+            <a:ext cx="3520440" cy="4709160"/>
           </a:xfrm>
           <a:prstGeom prst="roundRect">
             <a:avLst>
-              <a:gd name="adj" fmla="val 2449"/>
+              <a:gd name="adj" fmla="val 3117"/>
             </a:avLst>
           </a:prstGeom>
           <a:solidFill>
@@ -4826,8 +6541,8 @@
         </p:nvSpPr>
         <p:spPr>
           <a:xfrm>
-            <a:off x="6492240" y="1920240"/>
-            <a:ext cx="594360" cy="594360"/>
+            <a:off x="4663440" y="1691640"/>
+            <a:ext cx="548640" cy="548640"/>
           </a:xfrm>
           <a:prstGeom prst="ellipse">
             <a:avLst/>
@@ -4846,8 +6561,8 @@
         </p:nvSpPr>
         <p:spPr>
           <a:xfrm>
-            <a:off x="6492240" y="1920240"/>
-            <a:ext cx="594360" cy="594360"/>
+            <a:off x="4663440" y="1691640"/>
+            <a:ext cx="548640" cy="548640"/>
           </a:xfrm>
           <a:prstGeom prst="rect">
             <a:avLst/>
@@ -4863,7 +6578,7 @@
               <a:buNone/>
             </a:pPr>
             <a:r>
-              <a:rPr lang="en-US" sz="2200" b="1" dirty="0">
+              <a:rPr lang="en-US" sz="2000" b="1" dirty="0">
                 <a:solidFill>
                   <a:srgbClr val="FFFFFF"/>
                 </a:solidFill>
@@ -4873,7 +6588,7 @@
               </a:rPr>
               <a:t>2</a:t>
             </a:r>
-            <a:endParaRPr lang="en-US" sz="2200" dirty="0"/>
+            <a:endParaRPr lang="en-US" sz="2000" dirty="0"/>
           </a:p>
         </p:txBody>
       </p:sp>
@@ -4885,24 +6600,27 @@
         </p:nvSpPr>
         <p:spPr>
           <a:xfrm>
-            <a:off x="6492240" y="2697480"/>
-            <a:ext cx="4480560" cy="822960"/>
-          </a:xfrm>
-          <a:prstGeom prst="rect">
-            <a:avLst/>
-          </a:prstGeom>
-          <a:noFill/>
-          <a:ln/>
-        </p:spPr>
-        <p:txBody>
-          <a:bodyPr wrap="square" rtlCol="0" anchor="ctr"/>
-          <a:lstStyle/>
-          <a:p>
-            <a:pPr indent="0" marL="0">
-              <a:buNone/>
-            </a:pPr>
-            <a:r>
-              <a:rPr lang="en-US" sz="1900" b="1" dirty="0">
+            <a:off x="4663440" y="2377440"/>
+            <a:ext cx="2880360" cy="1051560"/>
+          </a:xfrm>
+          <a:prstGeom prst="rect">
+            <a:avLst/>
+          </a:prstGeom>
+          <a:noFill/>
+          <a:ln/>
+        </p:spPr>
+        <p:txBody>
+          <a:bodyPr wrap="square" rtlCol="0" anchor="ctr"/>
+          <a:lstStyle/>
+          <a:p>
+            <a:pPr indent="0" marL="0">
+              <a:lnSpc>
+                <a:spcPts val="1900"/>
+              </a:lnSpc>
+              <a:buNone/>
+            </a:pPr>
+            <a:r>
+              <a:rPr lang="en-US" sz="1600" b="1" dirty="0">
                 <a:solidFill>
                   <a:srgbClr val="1E2761"/>
                 </a:solidFill>
@@ -4912,7 +6630,7 @@
               </a:rPr>
               <a:t>How should budget be spent?</a:t>
             </a:r>
-            <a:endParaRPr lang="en-US" sz="1900" dirty="0"/>
+            <a:endParaRPr lang="en-US" sz="1600" dirty="0"/>
           </a:p>
         </p:txBody>
       </p:sp>
@@ -4924,8 +6642,167 @@
         </p:nvSpPr>
         <p:spPr>
           <a:xfrm>
-            <a:off x="6492240" y="3474720"/>
-            <a:ext cx="4480560" cy="2286000"/>
+            <a:off x="4663440" y="3520440"/>
+            <a:ext cx="2880360" cy="2331720"/>
+          </a:xfrm>
+          <a:prstGeom prst="rect">
+            <a:avLst/>
+          </a:prstGeom>
+          <a:noFill/>
+          <a:ln/>
+        </p:spPr>
+        <p:txBody>
+          <a:bodyPr wrap="square" rtlCol="0" anchor="ctr"/>
+          <a:lstStyle/>
+          <a:p>
+            <a:pPr indent="0" marL="0">
+              <a:lnSpc>
+                <a:spcPts val="1600"/>
+              </a:lnSpc>
+              <a:buNone/>
+            </a:pPr>
+            <a:r>
+              <a:rPr lang="en-US" sz="1150" dirty="0">
+                <a:solidFill>
+                  <a:srgbClr val="1A1A2E"/>
+                </a:solidFill>
+                <a:latin typeface="Calibri" pitchFamily="34" charset="0"/>
+                <a:ea typeface="Calibri" pitchFamily="34" charset="-122"/>
+                <a:cs typeface="Calibri" pitchFamily="34" charset="-120"/>
+              </a:rPr>
+              <a:t>Given a fixed weekly budget, how should it split across restaurants, gyms, bars, and waiting rooms — accounting for each venue type's own diminishing-returns curve?</a:t>
+            </a:r>
+            <a:endParaRPr lang="en-US" sz="1150" dirty="0"/>
+          </a:p>
+          <a:p>
+            <a:pPr indent="0" marL="0">
+              <a:lnSpc>
+                <a:spcPts val="1600"/>
+              </a:lnSpc>
+              <a:buNone/>
+            </a:pPr>
+            <a:endParaRPr lang="en-US" sz="1150" dirty="0"/>
+          </a:p>
+          <a:p>
+            <a:pPr indent="0" marL="0">
+              <a:lnSpc>
+                <a:spcPts val="1600"/>
+              </a:lnSpc>
+              <a:buNone/>
+            </a:pPr>
+            <a:r>
+              <a:rPr lang="en-US" sz="1150" dirty="0">
+                <a:solidFill>
+                  <a:srgbClr val="1A1A2E"/>
+                </a:solidFill>
+                <a:latin typeface="Calibri" pitchFamily="34" charset="0"/>
+                <a:ea typeface="Calibri" pitchFamily="34" charset="-122"/>
+                <a:cs typeface="Calibri" pitchFamily="34" charset="-120"/>
+              </a:rPr>
+              <a:t>The media-planning / pricing question advertisers ask before they commit spend.</a:t>
+            </a:r>
+            <a:endParaRPr lang="en-US" sz="1150" dirty="0"/>
+          </a:p>
+        </p:txBody>
+      </p:sp>
+      <p:sp>
+        <p:nvSpPr>
+          <p:cNvPr id="13" name="Shape 11"/>
+          <p:cNvSpPr/>
+          <p:nvPr/>
+        </p:nvSpPr>
+        <p:spPr>
+          <a:xfrm>
+            <a:off x="8138160" y="1371600"/>
+            <a:ext cx="3520440" cy="4709160"/>
+          </a:xfrm>
+          <a:prstGeom prst="roundRect">
+            <a:avLst>
+              <a:gd name="adj" fmla="val 3117"/>
+            </a:avLst>
+          </a:prstGeom>
+          <a:solidFill>
+            <a:srgbClr val="F5F7FC"/>
+          </a:solidFill>
+          <a:ln/>
+          <a:effectLst>
+            <a:outerShdw sx="100000" sy="100000" kx="0" ky="0" algn="bl" rotWithShape="0" blurRad="76200" dist="38100" dir="5400000">
+              <a:srgbClr val="888888">
+                <a:alpha val="25000"/>
+              </a:srgbClr>
+            </a:outerShdw>
+          </a:effectLst>
+        </p:spPr>
+      </p:sp>
+      <p:sp>
+        <p:nvSpPr>
+          <p:cNvPr id="14" name="Shape 12"/>
+          <p:cNvSpPr/>
+          <p:nvPr/>
+        </p:nvSpPr>
+        <p:spPr>
+          <a:xfrm>
+            <a:off x="8458200" y="1691640"/>
+            <a:ext cx="548640" cy="548640"/>
+          </a:xfrm>
+          <a:prstGeom prst="ellipse">
+            <a:avLst/>
+          </a:prstGeom>
+          <a:solidFill>
+            <a:srgbClr val="1E2761"/>
+          </a:solidFill>
+          <a:ln/>
+        </p:spPr>
+      </p:sp>
+      <p:sp>
+        <p:nvSpPr>
+          <p:cNvPr id="15" name="Text 13"/>
+          <p:cNvSpPr/>
+          <p:nvPr/>
+        </p:nvSpPr>
+        <p:spPr>
+          <a:xfrm>
+            <a:off x="8458200" y="1691640"/>
+            <a:ext cx="548640" cy="548640"/>
+          </a:xfrm>
+          <a:prstGeom prst="rect">
+            <a:avLst/>
+          </a:prstGeom>
+          <a:noFill/>
+          <a:ln/>
+        </p:spPr>
+        <p:txBody>
+          <a:bodyPr wrap="square" rtlCol="0" anchor="ctr"/>
+          <a:lstStyle/>
+          <a:p>
+            <a:pPr algn="ctr" indent="0" marL="0">
+              <a:buNone/>
+            </a:pPr>
+            <a:r>
+              <a:rPr lang="en-US" sz="2000" b="1" dirty="0">
+                <a:solidFill>
+                  <a:srgbClr val="FFFFFF"/>
+                </a:solidFill>
+                <a:latin typeface="Calibri" pitchFamily="34" charset="0"/>
+                <a:ea typeface="Calibri" pitchFamily="34" charset="-122"/>
+                <a:cs typeface="Calibri" pitchFamily="34" charset="-120"/>
+              </a:rPr>
+              <a:t>3</a:t>
+            </a:r>
+            <a:endParaRPr lang="en-US" sz="2000" dirty="0"/>
+          </a:p>
+        </p:txBody>
+      </p:sp>
+      <p:sp>
+        <p:nvSpPr>
+          <p:cNvPr id="16" name="Text 14"/>
+          <p:cNvSpPr/>
+          <p:nvPr/>
+        </p:nvSpPr>
+        <p:spPr>
+          <a:xfrm>
+            <a:off x="8458200" y="2377440"/>
+            <a:ext cx="2880360" cy="1051560"/>
           </a:xfrm>
           <a:prstGeom prst="rect">
             <a:avLst/>
@@ -4944,7 +6821,49 @@
               <a:buNone/>
             </a:pPr>
             <a:r>
-              <a:rPr lang="en-US" sz="1300" dirty="0">
+              <a:rPr lang="en-US" sz="1600" b="1" dirty="0">
+                <a:solidFill>
+                  <a:srgbClr val="1E2761"/>
+                </a:solidFill>
+                <a:latin typeface="Cambria" pitchFamily="34" charset="0"/>
+                <a:ea typeface="Cambria" pitchFamily="34" charset="-122"/>
+                <a:cs typeface="Cambria" pitchFamily="34" charset="-120"/>
+              </a:rPr>
+              <a:t>Where's Atmosphere's own revenue upside?</a:t>
+            </a:r>
+            <a:endParaRPr lang="en-US" sz="1600" dirty="0"/>
+          </a:p>
+        </p:txBody>
+      </p:sp>
+      <p:sp>
+        <p:nvSpPr>
+          <p:cNvPr id="17" name="Text 15"/>
+          <p:cNvSpPr/>
+          <p:nvPr/>
+        </p:nvSpPr>
+        <p:spPr>
+          <a:xfrm>
+            <a:off x="8458200" y="3520440"/>
+            <a:ext cx="2880360" cy="2331720"/>
+          </a:xfrm>
+          <a:prstGeom prst="rect">
+            <a:avLst/>
+          </a:prstGeom>
+          <a:noFill/>
+          <a:ln/>
+        </p:spPr>
+        <p:txBody>
+          <a:bodyPr wrap="square" rtlCol="0" anchor="ctr"/>
+          <a:lstStyle/>
+          <a:p>
+            <a:pPr indent="0" marL="0">
+              <a:lnSpc>
+                <a:spcPts val="1600"/>
+              </a:lnSpc>
+              <a:buNone/>
+            </a:pPr>
+            <a:r>
+              <a:rPr lang="en-US" sz="1150" dirty="0">
                 <a:solidFill>
                   <a:srgbClr val="1A1A2E"/>
                 </a:solidFill>
@@ -4952,28 +6871,28 @@
                 <a:ea typeface="Calibri" pitchFamily="34" charset="-122"/>
                 <a:cs typeface="Calibri" pitchFamily="34" charset="-120"/>
               </a:rPr>
-              <a:t>Given a fixed weekly budget, how should it be split across restaurants, gyms, bars, and waiting rooms — accounting for each venue type's own diminishing-returns curve?</a:t>
-            </a:r>
-            <a:endParaRPr lang="en-US" sz="1300" dirty="0"/>
+              <a:t>Which existing venues are under-monetized relative to their own traffic and quality — and which prospective venues are worth prioritizing for network expansion?</a:t>
+            </a:r>
+            <a:endParaRPr lang="en-US" sz="1150" dirty="0"/>
           </a:p>
           <a:p>
             <a:pPr indent="0" marL="0">
               <a:lnSpc>
-                <a:spcPts val="1900"/>
+                <a:spcPts val="1600"/>
               </a:lnSpc>
               <a:buNone/>
             </a:pPr>
-            <a:endParaRPr lang="en-US" sz="1300" dirty="0"/>
+            <a:endParaRPr lang="en-US" sz="1150" dirty="0"/>
           </a:p>
           <a:p>
             <a:pPr indent="0" marL="0">
               <a:lnSpc>
-                <a:spcPts val="1900"/>
+                <a:spcPts val="1600"/>
               </a:lnSpc>
               <a:buNone/>
             </a:pPr>
             <a:r>
-              <a:rPr lang="en-US" sz="1300" dirty="0">
+              <a:rPr lang="en-US" sz="1150" dirty="0">
                 <a:solidFill>
                   <a:srgbClr val="1A1A2E"/>
                 </a:solidFill>
@@ -4981,15 +6900,15 @@
                 <a:ea typeface="Calibri" pitchFamily="34" charset="-122"/>
                 <a:cs typeface="Calibri" pitchFamily="34" charset="-120"/>
               </a:rPr>
-              <a:t>This is the media-planning / pricing question advertisers ask before they commit spend.</a:t>
-            </a:r>
-            <a:endParaRPr lang="en-US" sz="1300" dirty="0"/>
-          </a:p>
-        </p:txBody>
-      </p:sp>
-      <p:sp>
-        <p:nvSpPr>
-          <p:cNvPr id="13" name="Text 11"/>
+              <a:t>Phase 2: Atmosphere's own buy-side question, not the advertiser's.</a:t>
+            </a:r>
+            <a:endParaRPr lang="en-US" sz="1150" dirty="0"/>
+          </a:p>
+        </p:txBody>
+      </p:sp>
+      <p:sp>
+        <p:nvSpPr>
+          <p:cNvPr id="18" name="Text 16"/>
           <p:cNvSpPr/>
           <p:nvPr/>
         </p:nvSpPr>
@@ -5028,7 +6947,7 @@
       </p:sp>
       <p:sp>
         <p:nvSpPr>
-          <p:cNvPr id="14" name="Text 12"/>
+          <p:cNvPr id="19" name="Text 17"/>
           <p:cNvSpPr/>
           <p:nvPr/>
         </p:nvSpPr>
@@ -8802,7 +10721,7 @@
                 <a:ea typeface="Cambria" pitchFamily="34" charset="-122"/>
                 <a:cs typeface="Cambria" pitchFamily="34" charset="-120"/>
               </a:rPr>
-              <a:t>Next: the other side of the business</a:t>
+              <a:t>The other side of the business</a:t>
             </a:r>
             <a:endParaRPr lang="en-US" sz="2800" dirty="0"/>
           </a:p>
@@ -8841,7 +10760,7 @@
                 <a:ea typeface="Calibri" pitchFamily="34" charset="-122"/>
                 <a:cs typeface="Calibri" pitchFamily="34" charset="-120"/>
               </a:rPr>
-              <a:t>Phase 1 (built) answers the advertising side. Phase 2 (designed) answers the venue-network side.</a:t>
+              <a:t>Phase 1 answers the advertising side. Phase 2 answers the venue-network side — both built, one connected system.</a:t>
             </a:r>
             <a:endParaRPr lang="en-US" sz="1350" dirty="0"/>
           </a:p>
@@ -8878,23 +10797,23 @@
         <p:spPr>
           <a:xfrm>
             <a:off x="914400" y="1965960"/>
-            <a:ext cx="4480560" cy="457200"/>
-          </a:xfrm>
-          <a:prstGeom prst="rect">
-            <a:avLst/>
-          </a:prstGeom>
-          <a:noFill/>
-          <a:ln/>
-        </p:spPr>
-        <p:txBody>
-          <a:bodyPr wrap="square" rtlCol="0" anchor="ctr"/>
-          <a:lstStyle/>
-          <a:p>
-            <a:pPr indent="0" marL="0">
-              <a:buNone/>
-            </a:pPr>
-            <a:r>
-              <a:rPr lang="en-US" sz="1700" b="1" dirty="0">
+            <a:ext cx="4480560" cy="594360"/>
+          </a:xfrm>
+          <a:prstGeom prst="rect">
+            <a:avLst/>
+          </a:prstGeom>
+          <a:noFill/>
+          <a:ln/>
+        </p:spPr>
+        <p:txBody>
+          <a:bodyPr wrap="square" rtlCol="0" anchor="ctr"/>
+          <a:lstStyle/>
+          <a:p>
+            <a:pPr indent="0" marL="0">
+              <a:buNone/>
+            </a:pPr>
+            <a:r>
+              <a:rPr lang="en-US" sz="1600" b="1" dirty="0">
                 <a:solidFill>
                   <a:srgbClr val="FFFFFF"/>
                 </a:solidFill>
@@ -8902,9 +10821,9 @@
                 <a:ea typeface="Cambria" pitchFamily="34" charset="-122"/>
                 <a:cs typeface="Cambria" pitchFamily="34" charset="-120"/>
               </a:rPr>
-              <a:t>Phase 1 — Built</a:t>
-            </a:r>
-            <a:endParaRPr lang="en-US" sz="1700" dirty="0"/>
+              <a:t>Phase 1 — Advertising incrementality</a:t>
+            </a:r>
+            <a:endParaRPr lang="en-US" sz="1600" dirty="0"/>
           </a:p>
         </p:txBody>
       </p:sp>
@@ -8916,7 +10835,7 @@
         </p:nvSpPr>
         <p:spPr>
           <a:xfrm>
-            <a:off x="914400" y="2606040"/>
+            <a:off x="914400" y="2743200"/>
             <a:ext cx="4480560" cy="594360"/>
           </a:xfrm>
           <a:prstGeom prst="rect">
@@ -8931,12 +10850,12 @@
           <a:p>
             <a:pPr indent="0" marL="0">
               <a:lnSpc>
-                <a:spcPts val="1600"/>
+                <a:spcPts val="1500"/>
               </a:lnSpc>
               <a:buNone/>
             </a:pPr>
             <a:r>
-              <a:rPr lang="en-US" sz="1250" dirty="0">
+              <a:rPr lang="en-US" sz="1200" dirty="0">
                 <a:solidFill>
                   <a:srgbClr val="FFFFFF"/>
                 </a:solidFill>
@@ -8946,7 +10865,7 @@
               </a:rPr>
               <a:t>• Prove and price advertising incrementality</a:t>
             </a:r>
-            <a:endParaRPr lang="en-US" sz="1250" dirty="0"/>
+            <a:endParaRPr lang="en-US" sz="1200" dirty="0"/>
           </a:p>
         </p:txBody>
       </p:sp>
@@ -8958,7 +10877,7 @@
         </p:nvSpPr>
         <p:spPr>
           <a:xfrm>
-            <a:off x="914400" y="3291840"/>
+            <a:off x="914400" y="3401568"/>
             <a:ext cx="4480560" cy="594360"/>
           </a:xfrm>
           <a:prstGeom prst="rect">
@@ -8973,12 +10892,12 @@
           <a:p>
             <a:pPr indent="0" marL="0">
               <a:lnSpc>
-                <a:spcPts val="1600"/>
+                <a:spcPts val="1500"/>
               </a:lnSpc>
               <a:buNone/>
             </a:pPr>
             <a:r>
-              <a:rPr lang="en-US" sz="1250" dirty="0">
+              <a:rPr lang="en-US" sz="1200" dirty="0">
                 <a:solidFill>
                   <a:srgbClr val="FFFFFF"/>
                 </a:solidFill>
@@ -8988,7 +10907,7 @@
               </a:rPr>
               <a:t>• Feeds go-to-market: sell-side differentiator, client trust</a:t>
             </a:r>
-            <a:endParaRPr lang="en-US" sz="1250" dirty="0"/>
+            <a:endParaRPr lang="en-US" sz="1200" dirty="0"/>
           </a:p>
         </p:txBody>
       </p:sp>
@@ -9000,7 +10919,7 @@
         </p:nvSpPr>
         <p:spPr>
           <a:xfrm>
-            <a:off x="914400" y="3977640"/>
+            <a:off x="914400" y="4059936"/>
             <a:ext cx="4480560" cy="594360"/>
           </a:xfrm>
           <a:prstGeom prst="rect">
@@ -9015,12 +10934,12 @@
           <a:p>
             <a:pPr indent="0" marL="0">
               <a:lnSpc>
-                <a:spcPts val="1600"/>
+                <a:spcPts val="1500"/>
               </a:lnSpc>
               <a:buNone/>
             </a:pPr>
             <a:r>
-              <a:rPr lang="en-US" sz="1250" dirty="0">
+              <a:rPr lang="en-US" sz="1200" dirty="0">
                 <a:solidFill>
                   <a:srgbClr val="FFFFFF"/>
                 </a:solidFill>
@@ -9030,7 +10949,7 @@
               </a:rPr>
               <a:t>• RCT + synthetic control + calibrated MMM + budget DP</a:t>
             </a:r>
-            <a:endParaRPr lang="en-US" sz="1250" dirty="0"/>
+            <a:endParaRPr lang="en-US" sz="1200" dirty="0"/>
           </a:p>
         </p:txBody>
       </p:sp>
@@ -9057,12 +10976,12 @@
           <a:p>
             <a:pPr indent="0" marL="0">
               <a:lnSpc>
-                <a:spcPts val="1400"/>
+                <a:spcPts val="1300"/>
               </a:lnSpc>
               <a:buNone/>
             </a:pPr>
             <a:r>
-              <a:rPr lang="en-US" sz="1050" i="1" dirty="0">
+              <a:rPr lang="en-US" sz="1000" i="1" dirty="0">
                 <a:solidFill>
                   <a:srgbClr val="CADCFC"/>
                 </a:solidFill>
@@ -9070,9 +10989,9 @@
                 <a:ea typeface="Calibri" pitchFamily="34" charset="-122"/>
                 <a:cs typeface="Calibri" pitchFamily="34" charset="-120"/>
               </a:rPr>
-              <a:t>Feeds Phase 2 as a validated causal-value input, not a separate silo.</a:t>
-            </a:r>
-            <a:endParaRPr lang="en-US" sz="1050" dirty="0"/>
+              <a:t>Feeds Phase 2 as a validated causal-value input (calibrated per-exposure lift), not a separate silo.</a:t>
+            </a:r>
+            <a:endParaRPr lang="en-US" sz="1000" dirty="0"/>
           </a:p>
         </p:txBody>
       </p:sp>
@@ -9107,23 +11026,23 @@
         <p:spPr>
           <a:xfrm>
             <a:off x="6583680" y="1965960"/>
-            <a:ext cx="4480560" cy="457200"/>
-          </a:xfrm>
-          <a:prstGeom prst="rect">
-            <a:avLst/>
-          </a:prstGeom>
-          <a:noFill/>
-          <a:ln/>
-        </p:spPr>
-        <p:txBody>
-          <a:bodyPr wrap="square" rtlCol="0" anchor="ctr"/>
-          <a:lstStyle/>
-          <a:p>
-            <a:pPr indent="0" marL="0">
-              <a:buNone/>
-            </a:pPr>
-            <a:r>
-              <a:rPr lang="en-US" sz="1700" b="1" dirty="0">
+            <a:ext cx="4480560" cy="594360"/>
+          </a:xfrm>
+          <a:prstGeom prst="rect">
+            <a:avLst/>
+          </a:prstGeom>
+          <a:noFill/>
+          <a:ln/>
+        </p:spPr>
+        <p:txBody>
+          <a:bodyPr wrap="square" rtlCol="0" anchor="ctr"/>
+          <a:lstStyle/>
+          <a:p>
+            <a:pPr indent="0" marL="0">
+              <a:buNone/>
+            </a:pPr>
+            <a:r>
+              <a:rPr lang="en-US" sz="1600" b="1" dirty="0">
                 <a:solidFill>
                   <a:srgbClr val="FFFFFF"/>
                 </a:solidFill>
@@ -9131,9 +11050,9 @@
                 <a:ea typeface="Cambria" pitchFamily="34" charset="-122"/>
                 <a:cs typeface="Cambria" pitchFamily="34" charset="-120"/>
               </a:rPr>
-              <a:t>Phase 2 — Designed</a:t>
-            </a:r>
-            <a:endParaRPr lang="en-US" sz="1700" dirty="0"/>
+              <a:t>Phase 2 — Venue economics</a:t>
+            </a:r>
+            <a:endParaRPr lang="en-US" sz="1600" dirty="0"/>
           </a:p>
         </p:txBody>
       </p:sp>
@@ -9145,7 +11064,7 @@
         </p:nvSpPr>
         <p:spPr>
           <a:xfrm>
-            <a:off x="6583680" y="2606040"/>
+            <a:off x="6583680" y="2743200"/>
             <a:ext cx="4480560" cy="594360"/>
           </a:xfrm>
           <a:prstGeom prst="rect">
@@ -9160,12 +11079,12 @@
           <a:p>
             <a:pPr indent="0" marL="0">
               <a:lnSpc>
-                <a:spcPts val="1600"/>
+                <a:spcPts val="1500"/>
               </a:lnSpc>
               <a:buNone/>
             </a:pPr>
             <a:r>
-              <a:rPr lang="en-US" sz="1250" dirty="0">
+              <a:rPr lang="en-US" sz="1200" dirty="0">
                 <a:solidFill>
                   <a:srgbClr val="FFFFFF"/>
                 </a:solidFill>
@@ -9173,9 +11092,9 @@
                 <a:ea typeface="Calibri" pitchFamily="34" charset="-122"/>
                 <a:cs typeface="Calibri" pitchFamily="34" charset="-120"/>
               </a:rPr>
-              <a:t>• Predict a venue's intrinsic ad-revenue potential</a:t>
-            </a:r>
-            <a:endParaRPr lang="en-US" sz="1250" dirty="0"/>
+              <a:t>• Predict a venue's realized ad-revenue from its characteristics</a:t>
+            </a:r>
+            <a:endParaRPr lang="en-US" sz="1200" dirty="0"/>
           </a:p>
         </p:txBody>
       </p:sp>
@@ -9187,7 +11106,7 @@
         </p:nvSpPr>
         <p:spPr>
           <a:xfrm>
-            <a:off x="6583680" y="3291840"/>
+            <a:off x="6583680" y="3401568"/>
             <a:ext cx="4480560" cy="594360"/>
           </a:xfrm>
           <a:prstGeom prst="rect">
@@ -9202,12 +11121,12 @@
           <a:p>
             <a:pPr indent="0" marL="0">
               <a:lnSpc>
-                <a:spcPts val="1600"/>
+                <a:spcPts val="1500"/>
               </a:lnSpc>
               <a:buNone/>
             </a:pPr>
             <a:r>
-              <a:rPr lang="en-US" sz="1250" dirty="0">
+              <a:rPr lang="en-US" sz="1200" dirty="0">
                 <a:solidFill>
                   <a:srgbClr val="FFFFFF"/>
                 </a:solidFill>
@@ -9215,9 +11134,9 @@
                 <a:ea typeface="Calibri" pitchFamily="34" charset="-122"/>
                 <a:cs typeface="Calibri" pitchFamily="34" charset="-120"/>
               </a:rPr>
-              <a:t>• Prioritize prospective venues for acquisition</a:t>
-            </a:r>
-            <a:endParaRPr lang="en-US" sz="1250" dirty="0"/>
+              <a:t>• Flag under-monetized existing venues for sales/ops follow-up</a:t>
+            </a:r>
+            <a:endParaRPr lang="en-US" sz="1200" dirty="0"/>
           </a:p>
         </p:txBody>
       </p:sp>
@@ -9229,7 +11148,7 @@
         </p:nvSpPr>
         <p:spPr>
           <a:xfrm>
-            <a:off x="6583680" y="3977640"/>
+            <a:off x="6583680" y="4059936"/>
             <a:ext cx="4480560" cy="594360"/>
           </a:xfrm>
           <a:prstGeom prst="rect">
@@ -9244,12 +11163,12 @@
           <a:p>
             <a:pPr indent="0" marL="0">
               <a:lnSpc>
-                <a:spcPts val="1600"/>
+                <a:spcPts val="1500"/>
               </a:lnSpc>
               <a:buNone/>
             </a:pPr>
             <a:r>
-              <a:rPr lang="en-US" sz="1250" dirty="0">
+              <a:rPr lang="en-US" sz="1200" dirty="0">
                 <a:solidFill>
                   <a:srgbClr val="FFFFFF"/>
                 </a:solidFill>
@@ -9257,9 +11176,9 @@
                 <a:ea typeface="Calibri" pitchFamily="34" charset="-122"/>
                 <a:cs typeface="Calibri" pitchFamily="34" charset="-120"/>
               </a:rPr>
-              <a:t>• Flag under-monetized existing venues</a:t>
-            </a:r>
-            <a:endParaRPr lang="en-US" sz="1250" dirty="0"/>
+              <a:t>• Rank prospective venues for expansion priority</a:t>
+            </a:r>
+            <a:endParaRPr lang="en-US" sz="1200" dirty="0"/>
           </a:p>
         </p:txBody>
       </p:sp>
@@ -9271,7 +11190,7 @@
         </p:nvSpPr>
         <p:spPr>
           <a:xfrm>
-            <a:off x="6583680" y="4663440"/>
+            <a:off x="6583680" y="4718304"/>
             <a:ext cx="4480560" cy="594360"/>
           </a:xfrm>
           <a:prstGeom prst="rect">
@@ -9286,12 +11205,12 @@
           <a:p>
             <a:pPr indent="0" marL="0">
               <a:lnSpc>
-                <a:spcPts val="1600"/>
+                <a:spcPts val="1500"/>
               </a:lnSpc>
               <a:buNone/>
             </a:pPr>
             <a:r>
-              <a:rPr lang="en-US" sz="1250" dirty="0">
+              <a:rPr lang="en-US" sz="1200" dirty="0">
                 <a:solidFill>
                   <a:srgbClr val="FFFFFF"/>
                 </a:solidFill>
@@ -9299,9 +11218,9 @@
                 <a:ea typeface="Calibri" pitchFamily="34" charset="-122"/>
                 <a:cs typeface="Calibri" pitchFamily="34" charset="-120"/>
               </a:rPr>
-              <a:t>• GBM model, calibrated, with honest out-of-sample evaluation</a:t>
-            </a:r>
-            <a:endParaRPr lang="en-US" sz="1250" dirty="0"/>
+              <a:t>• Gradient-boosted trees, honest out-of-fold evaluation</a:t>
+            </a:r>
+            <a:endParaRPr lang="en-US" sz="1200" dirty="0"/>
           </a:p>
         </p:txBody>
       </p:sp>
@@ -9338,7 +11257,7 @@
                 <a:ea typeface="Calibri" pitchFamily="34" charset="-122"/>
                 <a:cs typeface="Calibri" pitchFamily="34" charset="-120"/>
               </a:rPr>
-              <a:t>“Smarter on both sides of the business” — the venue-side model shares its data foundation and its causal-value inputs with Phase 1, rather than being a disconnected second project.</a:t>
+              <a:t>“Smarter on both sides of the business” — the venue-side model shares its data foundation and Phase 1's causal-value input, rather than being a disconnected second project. Results on the next slide.</a:t>
             </a:r>
             <a:endParaRPr lang="en-US" sz="1150" dirty="0"/>
           </a:p>

</xml_diff>

<commit_message>
Present as one unified project; make the deck viewable on GitHub
Drop the "Phase 1 / Phase 2" build-order framing throughout README, deck,
dashboard, and source docstrings -- the advertising-measurement pipeline
and the venue-revenue model are described as one connected system (which
they already are, via the shared calibrated per-exposure-lift feature),
not two staged projects. Renames the phase2-labeled ground-truth file and
deck-data key to match.

Also commits a PDF export of the deck (GitHub renders PDFs inline) and
per-slide JPG renders embedded directly in the README, so the presentation
is viewable without downloading anything.

Co-Authored-By: Claude Sonnet 5 <noreply@anthropic.com>
Claude-Session: https://claude.ai/code/session_017jyLbEVWfmSvvuhbbFmqiC
</commit_message>
<xml_diff>
--- a/deck/AtmosphereTV_DOOH_Measurement.pptx
+++ b/deck/AtmosphereTV_DOOH_Measurement.pptx
@@ -3882,7 +3882,7 @@
                 <a:ea typeface="Cambria" pitchFamily="34" charset="-122"/>
                 <a:cs typeface="Cambria" pitchFamily="34" charset="-120"/>
               </a:rPr>
-              <a:t>Phase 2: predicting venue ad-revenue, honestly</a:t>
+              <a:t>Predicting venue ad-revenue, honestly</a:t>
             </a:r>
             <a:endParaRPr lang="en-US" sz="2500" dirty="0"/>
           </a:p>
@@ -3921,7 +3921,7 @@
                 <a:ea typeface="Calibri" pitchFamily="34" charset="-122"/>
                 <a:cs typeface="Calibri" pitchFamily="34" charset="-120"/>
               </a:rPr>
-              <a:t>Gradient-boosted trees on observable venue characteristics + Phase 1's calibrated per-exposure lift as a feature.</a:t>
+              <a:t>Gradient-boosted trees on observable venue characteristics + the calibrated per-exposure lift as a feature.</a:t>
             </a:r>
             <a:endParaRPr lang="en-US" sz="1250" dirty="0"/>
           </a:p>
@@ -5081,7 +5081,7 @@
                 <a:ea typeface="Calibri" pitchFamily="34" charset="-122"/>
                 <a:cs typeface="Calibri" pitchFamily="34" charset="-120"/>
               </a:rPr>
-              <a:t>Flags come from 5-fold out-of-fold predictions, never a model scoring the venue it was trained on. Phase 1's calibrated-lift feature carries near-zero importance — honest, since it's constant within venue_type once venue_type itself is a feature.</a:t>
+              <a:t>Flags come from 5-fold out-of-fold predictions, never a model scoring the venue it was trained on. The calibrated-lift feature carries near-zero importance — honest, since it's constant within venue_type once venue_type itself is a feature.</a:t>
             </a:r>
             <a:endParaRPr lang="en-US" sz="1000" dirty="0"/>
           </a:p>
@@ -5120,7 +5120,7 @@
                 <a:ea typeface="Calibri" pitchFamily="34" charset="-122"/>
                 <a:cs typeface="Calibri" pitchFamily="34" charset="-120"/>
               </a:rPr>
-              <a:t>Venue economics — Phase 2</a:t>
+              <a:t>Venue economics</a:t>
             </a:r>
             <a:endParaRPr lang="en-US" sz="900" dirty="0"/>
           </a:p>
@@ -5331,7 +5331,7 @@
                 <a:ea typeface="Calibri" pitchFamily="34" charset="-122"/>
                 <a:cs typeface="Calibri" pitchFamily="34" charset="-120"/>
               </a:rPr>
-              <a:t>All figures — Phase 1 and Phase 2 — are synthetic, with a known injected ground-truth effect used specifically to validate that each method recovers it before trusting it conceptually. Not a claim about any real company's data.</a:t>
+              <a:t>Every figure in this project is synthetic, with a known injected ground-truth effect used specifically to validate that each method recovers it before trusting it conceptually. Not a claim about any real company's data.</a:t>
             </a:r>
             <a:endParaRPr lang="en-US" sz="1200" dirty="0"/>
           </a:p>
@@ -5634,7 +5634,7 @@
                 <a:ea typeface="Calibri" pitchFamily="34" charset="-122"/>
                 <a:cs typeface="Calibri" pitchFamily="34" charset="-120"/>
               </a:rPr>
-              <a:t>The $/frequency-unit figures behind the budget allocator, and the ad-rate-card behind Phase 2's revenue model, are illustrative, editable placeholders — in production these come from Atmosphere's own rate card by venue type and daypart.</a:t>
+              <a:t>The $/frequency-unit figures behind the budget allocator, and the ad-rate-card behind the venue-revenue model, are illustrative, editable placeholders — in production these come from Atmosphere's own rate card by venue type and daypart.</a:t>
             </a:r>
             <a:endParaRPr lang="en-US" sz="1200" dirty="0"/>
           </a:p>
@@ -6187,7 +6187,7 @@
                 <a:ea typeface="Calibri" pitchFamily="34" charset="-122"/>
                 <a:cs typeface="Calibri" pitchFamily="34" charset="-120"/>
               </a:rPr>
-              <a:t>One connected system, not two projects: Phase 2's venue-revenue model reuses Phase 1's causal-value input, recovers latent ground truth at 0.95 correlation, and cleanly separates market-level effects from venue-level execution gaps.</a:t>
+              <a:t>One connected system, not two projects: the venue-revenue model reuses the causal pipeline's per-exposure value as an input, recovers latent ground truth at 0.95 correlation, and cleanly separates market-level effects from venue-level execution gaps.</a:t>
             </a:r>
             <a:endParaRPr lang="en-US" sz="1450" dirty="0"/>
           </a:p>
@@ -6900,7 +6900,7 @@
                 <a:ea typeface="Calibri" pitchFamily="34" charset="-122"/>
                 <a:cs typeface="Calibri" pitchFamily="34" charset="-120"/>
               </a:rPr>
-              <a:t>Phase 2: Atmosphere's own buy-side question, not the advertiser's.</a:t>
+              <a:t>Atmosphere's own buy-side question, not the advertiser's.</a:t>
             </a:r>
             <a:endParaRPr lang="en-US" sz="1150" dirty="0"/>
           </a:p>
@@ -10760,7 +10760,7 @@
                 <a:ea typeface="Calibri" pitchFamily="34" charset="-122"/>
                 <a:cs typeface="Calibri" pitchFamily="34" charset="-120"/>
               </a:rPr>
-              <a:t>Phase 1 answers the advertising side. Phase 2 answers the venue-network side — both built, one connected system.</a:t>
+              <a:t>One system answers the advertising side. The same system answers the venue-network side too.</a:t>
             </a:r>
             <a:endParaRPr lang="en-US" sz="1350" dirty="0"/>
           </a:p>
@@ -10821,7 +10821,7 @@
                 <a:ea typeface="Cambria" pitchFamily="34" charset="-122"/>
                 <a:cs typeface="Cambria" pitchFamily="34" charset="-120"/>
               </a:rPr>
-              <a:t>Phase 1 — Advertising incrementality</a:t>
+              <a:t>Advertising incrementality</a:t>
             </a:r>
             <a:endParaRPr lang="en-US" sz="1600" dirty="0"/>
           </a:p>
@@ -10989,7 +10989,7 @@
                 <a:ea typeface="Calibri" pitchFamily="34" charset="-122"/>
                 <a:cs typeface="Calibri" pitchFamily="34" charset="-120"/>
               </a:rPr>
-              <a:t>Feeds Phase 2 as a validated causal-value input (calibrated per-exposure lift), not a separate silo.</a:t>
+              <a:t>Feeds the venue-economics model as a validated causal-value input (calibrated per-exposure lift), not a separate silo.</a:t>
             </a:r>
             <a:endParaRPr lang="en-US" sz="1000" dirty="0"/>
           </a:p>
@@ -11050,7 +11050,7 @@
                 <a:ea typeface="Cambria" pitchFamily="34" charset="-122"/>
                 <a:cs typeface="Cambria" pitchFamily="34" charset="-120"/>
               </a:rPr>
-              <a:t>Phase 2 — Venue economics</a:t>
+              <a:t>Venue economics</a:t>
             </a:r>
             <a:endParaRPr lang="en-US" sz="1600" dirty="0"/>
           </a:p>
@@ -11257,7 +11257,7 @@
                 <a:ea typeface="Calibri" pitchFamily="34" charset="-122"/>
                 <a:cs typeface="Calibri" pitchFamily="34" charset="-120"/>
               </a:rPr>
-              <a:t>“Smarter on both sides of the business” — the venue-side model shares its data foundation and Phase 1's causal-value input, rather than being a disconnected second project. Results on the next slide.</a:t>
+              <a:t>“Smarter on both sides of the business” — the venue-side model shares its data foundation and causal-value input with the advertising side, rather than being a disconnected second project. Results on the next slide.</a:t>
             </a:r>
             <a:endParaRPr lang="en-US" sz="1150" dirty="0"/>
           </a:p>

</xml_diff>